<commit_message>
Template: add layouts (Titelfolie Kontakt, Inhalt und Bild mit Logo, Titel und Tabelle); skill uses the WU template
Co-Authored-By: Claude Sonnet 5.5 <noreply@anthropic.com>
Claude-Session: https://claude.ai/code/session_01RkWScMhuRmEB4zppSmB7Ri
</commit_message>
<xml_diff>
--- a/WT26-27/template.pptx
+++ b/WT26-27/template.pptx
@@ -29,6 +29,9 @@
     <p:sldId id="266" r:id="rId20"/>
     <p:sldId id="267" r:id="rId21"/>
     <p:sldId id="268" r:id="rId22"/>
+    <p:sldId id="313" r:id="rId39"/>
+    <p:sldId id="314" r:id="rId40"/>
+    <p:sldId id="315" r:id="rId41"/>
     <p:sldId id="269" r:id="rId23"/>
     <p:sldId id="270" r:id="rId24"/>
     <p:sldId id="271" r:id="rId25"/>
@@ -18707,6 +18710,981 @@
 </p:sldLayout>
 </file>
 
+<file path=ppt/slideLayouts/slideLayout16.xml><?xml version="1.0" encoding="utf-8"?>
+<p:sldLayout xmlns:a="http://schemas.openxmlformats.org/drawingml/2006/main" xmlns:r="http://schemas.openxmlformats.org/officeDocument/2006/relationships" xmlns:p="http://schemas.openxmlformats.org/presentationml/2006/main" showMasterSp="0" preserve="1" userDrawn="1">
+  <p:cSld name="Titelfolie Kontakt">
+    <p:bg>
+      <p:bgPr>
+        <a:blipFill dpi="0" rotWithShape="1">
+          <a:blip r:embed="rId2">
+            <a:lum/>
+          </a:blip>
+          <a:srcRect/>
+          <a:stretch>
+            <a:fillRect/>
+          </a:stretch>
+        </a:blipFill>
+        <a:effectLst/>
+      </p:bgPr>
+    </p:bg>
+    <p:spTree>
+      <p:nvGrpSpPr>
+        <p:cNvPr id="1" name=""/>
+        <p:cNvGrpSpPr/>
+        <p:nvPr/>
+      </p:nvGrpSpPr>
+      <p:grpSpPr>
+        <a:xfrm>
+          <a:off x="0" y="0"/>
+          <a:ext cx="0" cy="0"/>
+          <a:chOff x="0" y="0"/>
+          <a:chExt cx="0" cy="0"/>
+        </a:xfrm>
+      </p:grpSpPr>
+      <p:grpSp>
+        <p:nvGrpSpPr>
+          <p:cNvPr id="11" name="Gruppieren 10"/>
+          <p:cNvGrpSpPr/>
+          <p:nvPr userDrawn="1"/>
+        </p:nvGrpSpPr>
+        <p:grpSpPr>
+          <a:xfrm>
+            <a:off x="287338" y="603319"/>
+            <a:ext cx="8552850" cy="2037600"/>
+            <a:chOff x="287338" y="603319"/>
+            <a:chExt cx="8552850" cy="2037600"/>
+          </a:xfrm>
+        </p:grpSpPr>
+        <p:sp>
+          <p:nvSpPr>
+            <p:cNvPr id="14" name="Rechteck 13"/>
+            <p:cNvSpPr/>
+            <p:nvPr userDrawn="1"/>
+          </p:nvSpPr>
+          <p:spPr>
+            <a:xfrm>
+              <a:off x="6192000" y="603319"/>
+              <a:ext cx="2648188" cy="2037600"/>
+            </a:xfrm>
+            <a:prstGeom prst="rect">
+              <a:avLst/>
+            </a:prstGeom>
+            <a:solidFill>
+              <a:schemeClr val="bg1"/>
+            </a:solidFill>
+            <a:ln>
+              <a:noFill/>
+            </a:ln>
+          </p:spPr>
+          <p:style>
+            <a:lnRef idx="3">
+              <a:schemeClr val="lt1"/>
+            </a:lnRef>
+            <a:fillRef idx="1">
+              <a:schemeClr val="accent1"/>
+            </a:fillRef>
+            <a:effectRef idx="1">
+              <a:schemeClr val="accent1"/>
+            </a:effectRef>
+            <a:fontRef idx="minor">
+              <a:schemeClr val="lt1"/>
+            </a:fontRef>
+          </p:style>
+          <p:txBody>
+            <a:bodyPr rtlCol="0" anchor="ctr"/>
+            <a:lstStyle/>
+            <a:p>
+              <a:pPr algn="ctr"/>
+              <a:endParaRPr lang="en-GB" dirty="0"/>
+            </a:p>
+          </p:txBody>
+        </p:sp>
+        <p:sp>
+          <p:nvSpPr>
+            <p:cNvPr id="15" name="Rechteck 14"/>
+            <p:cNvSpPr/>
+            <p:nvPr userDrawn="1"/>
+          </p:nvSpPr>
+          <p:spPr bwMode="blackWhite">
+            <a:xfrm>
+              <a:off x="287338" y="603319"/>
+              <a:ext cx="5904662" cy="2037600"/>
+            </a:xfrm>
+            <a:prstGeom prst="rect">
+              <a:avLst/>
+            </a:prstGeom>
+            <a:solidFill>
+              <a:srgbClr val="0096D3">
+                <a:alpha val="89804"/>
+              </a:srgbClr>
+            </a:solidFill>
+            <a:ln>
+              <a:noFill/>
+            </a:ln>
+          </p:spPr>
+          <p:style>
+            <a:lnRef idx="3">
+              <a:schemeClr val="lt1"/>
+            </a:lnRef>
+            <a:fillRef idx="1">
+              <a:schemeClr val="accent1"/>
+            </a:fillRef>
+            <a:effectRef idx="1">
+              <a:schemeClr val="accent1"/>
+            </a:effectRef>
+            <a:fontRef idx="minor">
+              <a:schemeClr val="lt1"/>
+            </a:fontRef>
+          </p:style>
+          <p:txBody>
+            <a:bodyPr rtlCol="0" anchor="ctr"/>
+            <a:lstStyle/>
+            <a:p>
+              <a:pPr algn="ctr"/>
+              <a:endParaRPr lang="en-GB" dirty="0"/>
+            </a:p>
+          </p:txBody>
+        </p:sp>
+      </p:grpSp>
+      <p:sp>
+        <p:nvSpPr>
+          <p:cNvPr id="2" name="Titel 1"/>
+          <p:cNvSpPr>
+            <a:spLocks noGrp="1"/>
+          </p:cNvSpPr>
+          <p:nvPr userDrawn="1">
+            <p:ph type="ctrTitle" hasCustomPrompt="1"/>
+          </p:nvPr>
+        </p:nvSpPr>
+        <p:spPr bwMode="black">
+          <a:xfrm>
+            <a:off x="605406" y="1301365"/>
+            <a:ext cx="5436000" cy="1026000"/>
+          </a:xfrm>
+          <a:prstGeom prst="rect">
+            <a:avLst/>
+          </a:prstGeom>
+        </p:spPr>
+        <p:txBody>
+          <a:bodyPr tIns="0" anchor="ctr" anchorCtr="0">
+            <a:noAutofit/>
+          </a:bodyPr>
+          <a:lstStyle>
+            <a:lvl1pPr algn="l">
+              <a:lnSpc>
+                <a:spcPct val="100000"/>
+              </a:lnSpc>
+              <a:defRPr sz="3200" b="1" i="0" baseline="0">
+                <a:solidFill>
+                  <a:schemeClr val="bg1"/>
+                </a:solidFill>
+                <a:latin typeface="Georgia" charset="0"/>
+                <a:ea typeface="Georgia" charset="0"/>
+                <a:cs typeface="Georgia" charset="0"/>
+              </a:defRPr>
+            </a:lvl1pPr>
+          </a:lstStyle>
+          <a:p>
+            <a:r>
+              <a:rPr lang="en-GB" dirty="0"/>
+              <a:t>Max. 2 lines of text for header</a:t>
+            </a:r>
+          </a:p>
+        </p:txBody>
+      </p:sp>
+      <p:sp>
+        <p:nvSpPr>
+          <p:cNvPr id="3" name="Untertitel 2"/>
+          <p:cNvSpPr>
+            <a:spLocks noGrp="1"/>
+          </p:cNvSpPr>
+          <p:nvPr userDrawn="1">
+            <p:ph type="subTitle" idx="1" hasCustomPrompt="1"/>
+          </p:nvPr>
+        </p:nvSpPr>
+        <p:spPr bwMode="black">
+          <a:xfrm>
+            <a:off x="605406" y="993080"/>
+            <a:ext cx="5436000" cy="351533"/>
+          </a:xfrm>
+        </p:spPr>
+        <p:txBody>
+          <a:bodyPr tIns="0" bIns="0">
+            <a:noAutofit/>
+          </a:bodyPr>
+          <a:lstStyle>
+            <a:lvl1pPr marL="0" indent="0" algn="l">
+              <a:lnSpc>
+                <a:spcPct val="100000"/>
+              </a:lnSpc>
+              <a:buNone/>
+              <a:defRPr sz="1800" b="1" i="0" baseline="0">
+                <a:solidFill>
+                  <a:schemeClr val="tx1"/>
+                </a:solidFill>
+                <a:latin typeface="Verdana" charset="0"/>
+                <a:ea typeface="Verdana" charset="0"/>
+                <a:cs typeface="Verdana" charset="0"/>
+              </a:defRPr>
+            </a:lvl1pPr>
+            <a:lvl2pPr marL="457153" indent="0" algn="ctr">
+              <a:buNone/>
+              <a:defRPr>
+                <a:solidFill>
+                  <a:schemeClr val="tx1">
+                    <a:tint val="75000"/>
+                  </a:schemeClr>
+                </a:solidFill>
+              </a:defRPr>
+            </a:lvl2pPr>
+            <a:lvl3pPr marL="914306" indent="0" algn="ctr">
+              <a:buNone/>
+              <a:defRPr>
+                <a:solidFill>
+                  <a:schemeClr val="tx1">
+                    <a:tint val="75000"/>
+                  </a:schemeClr>
+                </a:solidFill>
+              </a:defRPr>
+            </a:lvl3pPr>
+            <a:lvl4pPr marL="1371460" indent="0" algn="ctr">
+              <a:buNone/>
+              <a:defRPr>
+                <a:solidFill>
+                  <a:schemeClr val="tx1">
+                    <a:tint val="75000"/>
+                  </a:schemeClr>
+                </a:solidFill>
+              </a:defRPr>
+            </a:lvl4pPr>
+            <a:lvl5pPr marL="1828613" indent="0" algn="ctr">
+              <a:buNone/>
+              <a:defRPr>
+                <a:solidFill>
+                  <a:schemeClr val="tx1">
+                    <a:tint val="75000"/>
+                  </a:schemeClr>
+                </a:solidFill>
+              </a:defRPr>
+            </a:lvl5pPr>
+            <a:lvl6pPr marL="2285767" indent="0" algn="ctr">
+              <a:buNone/>
+              <a:defRPr>
+                <a:solidFill>
+                  <a:schemeClr val="tx1">
+                    <a:tint val="75000"/>
+                  </a:schemeClr>
+                </a:solidFill>
+              </a:defRPr>
+            </a:lvl6pPr>
+            <a:lvl7pPr marL="2742920" indent="0" algn="ctr">
+              <a:buNone/>
+              <a:defRPr>
+                <a:solidFill>
+                  <a:schemeClr val="tx1">
+                    <a:tint val="75000"/>
+                  </a:schemeClr>
+                </a:solidFill>
+              </a:defRPr>
+            </a:lvl7pPr>
+            <a:lvl8pPr marL="3200073" indent="0" algn="ctr">
+              <a:buNone/>
+              <a:defRPr>
+                <a:solidFill>
+                  <a:schemeClr val="tx1">
+                    <a:tint val="75000"/>
+                  </a:schemeClr>
+                </a:solidFill>
+              </a:defRPr>
+            </a:lvl8pPr>
+            <a:lvl9pPr marL="3657227" indent="0" algn="ctr">
+              <a:buNone/>
+              <a:defRPr>
+                <a:solidFill>
+                  <a:schemeClr val="tx1">
+                    <a:tint val="75000"/>
+                  </a:schemeClr>
+                </a:solidFill>
+              </a:defRPr>
+            </a:lvl9pPr>
+          </a:lstStyle>
+          <a:p>
+            <a:r>
+              <a:rPr lang="en-GB" dirty="0"/>
+              <a:t>Add subtitle here if required</a:t>
+            </a:r>
+          </a:p>
+        </p:txBody>
+      </p:sp>
+      <p:sp>
+        <p:nvSpPr>
+          <p:cNvPr id="10" name="Textplatzhalter 9"/>
+          <p:cNvSpPr>
+            <a:spLocks noGrp="1"/>
+          </p:cNvSpPr>
+          <p:nvPr>
+            <p:ph type="body" sz="quarter" idx="11" hasCustomPrompt="1"/>
+          </p:nvPr>
+        </p:nvSpPr>
+        <p:spPr bwMode="white">
+          <a:xfrm>
+            <a:off x="287338" y="2941638"/>
+            <a:ext cx="4284662" cy="1400000"/>
+          </a:xfrm>
+          <a:solidFill>
+            <a:schemeClr val="bg1">
+              <a:alpha val="90000"/>
+            </a:schemeClr>
+          </a:solidFill>
+        </p:spPr>
+        <p:txBody>
+          <a:bodyPr wrap="square" lIns="324000" tIns="216000" rIns="324000" bIns="216000" rtlCol="0" anchor="t" anchorCtr="0">
+            <a:spAutoFit/>
+          </a:bodyPr>
+          <a:lstStyle>
+            <a:lvl1pPr marL="0" indent="0">
+              <a:buNone/>
+              <a:defRPr lang="de-DE" sz="1200" baseline="0" dirty="0" smtClean="0"/>
+            </a:lvl1pPr>
+          </a:lstStyle>
+          <a:p>
+            <a:r>
+              <a:rPr lang="en-GB" dirty="0"/>
+              <a:t>Name and position</a:t>
+            </a:r>
+          </a:p>
+          <a:p>
+            <a:r>
+              <a:rPr lang="en-GB" dirty="0"/>
+              <a:t>Institute</a:t>
+            </a:r>
+          </a:p>
+          <a:p>
+            <a:r>
+              <a:rPr lang="en-GB" dirty="0"/>
+              <a:t>E-mail address</a:t>
+            </a:r>
+          </a:p>
+          <a:p>
+            <a:r>
+              <a:rPr lang="en-GB" dirty="0"/>
+              <a:t>Link, e.g. to office hours</a:t>
+            </a:r>
+          </a:p>
+        </p:txBody>
+      </p:sp>
+      <p:sp>
+        <p:nvSpPr>
+          <p:cNvPr id="12" name="Textplatzhalter 7"/>
+          <p:cNvSpPr>
+            <a:spLocks noGrp="1"/>
+          </p:cNvSpPr>
+          <p:nvPr>
+            <p:ph type="body" sz="quarter" idx="12" hasCustomPrompt="1"/>
+          </p:nvPr>
+        </p:nvSpPr>
+        <p:spPr bwMode="auto">
+          <a:xfrm>
+            <a:off x="457200" y="5426926"/>
+            <a:ext cx="1638300" cy="243623"/>
+          </a:xfrm>
+        </p:spPr>
+        <p:txBody>
+          <a:bodyPr>
+            <a:noAutofit/>
+          </a:bodyPr>
+          <a:lstStyle>
+            <a:lvl1pPr marL="0" indent="0">
+              <a:buNone/>
+              <a:defRPr sz="900" cap="all" baseline="0">
+                <a:solidFill>
+                  <a:schemeClr val="bg1"/>
+                </a:solidFill>
+              </a:defRPr>
+            </a:lvl1pPr>
+            <a:lvl2pPr marL="266700" indent="0">
+              <a:buNone/>
+              <a:defRPr sz="1050"/>
+            </a:lvl2pPr>
+            <a:lvl3pPr marL="541338" indent="0">
+              <a:buNone/>
+              <a:defRPr sz="1050"/>
+            </a:lvl3pPr>
+            <a:lvl4pPr marL="808038" indent="0">
+              <a:buNone/>
+              <a:defRPr sz="1000"/>
+            </a:lvl4pPr>
+            <a:lvl5pPr marL="1077913" indent="0">
+              <a:buNone/>
+              <a:defRPr sz="1000"/>
+            </a:lvl5pPr>
+          </a:lstStyle>
+          <a:p>
+            <a:pPr lvl="0"/>
+            <a:r>
+              <a:rPr lang="en-GB" dirty="0"/>
+              <a:t>State: </a:t>
+            </a:r>
+            <a:r>
+              <a:rPr lang="en-GB" dirty="0" err="1"/>
+              <a:t>xx.xx.xxxx</a:t>
+            </a:r>
+            <a:endParaRPr lang="en-GB" dirty="0"/>
+          </a:p>
+        </p:txBody>
+      </p:sp>
+      <p:pic>
+        <p:nvPicPr>
+          <p:cNvPr id="18" name="Grafik 17">
+            <a:extLst>
+              <a:ext uri="{FF2B5EF4-FFF2-40B4-BE49-F238E27FC236}">
+                <a16:creationId xmlns:a16="http://schemas.microsoft.com/office/drawing/2014/main" id="{35A845CD-2D10-42BB-97DB-CDA723EE9EBF}"/>
+              </a:ext>
+            </a:extLst>
+          </p:cNvPr>
+          <p:cNvPicPr>
+            <a:picLocks noChangeAspect="1"/>
+          </p:cNvPicPr>
+          <p:nvPr userDrawn="1"/>
+        </p:nvPicPr>
+        <p:blipFill>
+          <a:blip r:embed="rId3"/>
+          <a:stretch>
+            <a:fillRect/>
+          </a:stretch>
+        </p:blipFill>
+        <p:spPr>
+          <a:xfrm>
+            <a:off x="6579375" y="1065910"/>
+            <a:ext cx="1849165" cy="975600"/>
+          </a:xfrm>
+          <a:prstGeom prst="rect">
+            <a:avLst/>
+          </a:prstGeom>
+        </p:spPr>
+      </p:pic>
+      <p:pic>
+        <p:nvPicPr>
+          <p:cNvPr id="16" name="Grafik 15">
+            <a:extLst>
+              <a:ext uri="{FF2B5EF4-FFF2-40B4-BE49-F238E27FC236}">
+                <a16:creationId xmlns:a16="http://schemas.microsoft.com/office/drawing/2014/main" id="{1A49BD17-4238-4565-A4B6-2E20A7C19FA6}"/>
+              </a:ext>
+            </a:extLst>
+          </p:cNvPr>
+          <p:cNvPicPr>
+            <a:picLocks noChangeAspect="1"/>
+          </p:cNvPicPr>
+          <p:nvPr userDrawn="1"/>
+        </p:nvPicPr>
+        <p:blipFill>
+          <a:blip r:embed="rId4">
+            <a:extLst>
+              <a:ext uri="{28A0092B-C50C-407E-A947-70E740481C1C}">
+                <a14:useLocalDpi xmlns:a14="http://schemas.microsoft.com/office/drawing/2010/main" val="0"/>
+              </a:ext>
+            </a:extLst>
+          </a:blip>
+          <a:stretch>
+            <a:fillRect/>
+          </a:stretch>
+        </p:blipFill>
+        <p:spPr>
+          <a:xfrm>
+            <a:off x="6615113" y="5129960"/>
+            <a:ext cx="1835942" cy="317581"/>
+          </a:xfrm>
+          <a:prstGeom prst="rect">
+            <a:avLst/>
+          </a:prstGeom>
+        </p:spPr>
+      </p:pic>
+    </p:spTree>
+    <p:extLst>
+      <p:ext uri="{BB962C8B-B14F-4D97-AF65-F5344CB8AC3E}">
+        <p14:creationId xmlns:p14="http://schemas.microsoft.com/office/powerpoint/2010/main" val="1096689772"/>
+      </p:ext>
+    </p:extLst>
+  </p:cSld>
+  <p:clrMapOvr>
+    <a:masterClrMapping/>
+  </p:clrMapOvr>
+  <p:transition>
+    <p:fade/>
+  </p:transition>
+  <p:extLst>
+    <p:ext uri="{DCECCB84-F9BA-43D5-87BE-67443E8EF086}">
+      <p15:sldGuideLst xmlns:p15="http://schemas.microsoft.com/office/powerpoint/2012/main"/>
+    </p:ext>
+  </p:extLst>
+</p:sldLayout>
+</file>
+
+<file path=ppt/slideLayouts/slideLayout17.xml><?xml version="1.0" encoding="utf-8"?>
+<p:sldLayout xmlns:a="http://schemas.openxmlformats.org/drawingml/2006/main" xmlns:r="http://schemas.openxmlformats.org/officeDocument/2006/relationships" xmlns:p="http://schemas.openxmlformats.org/presentationml/2006/main" preserve="1" userDrawn="1">
+  <p:cSld name="Inhalt und Bild mit Logo">
+    <p:spTree>
+      <p:nvGrpSpPr>
+        <p:cNvPr id="1" name=""/>
+        <p:cNvGrpSpPr/>
+        <p:nvPr/>
+      </p:nvGrpSpPr>
+      <p:grpSpPr>
+        <a:xfrm>
+          <a:off x="0" y="0"/>
+          <a:ext cx="0" cy="0"/>
+          <a:chOff x="0" y="0"/>
+          <a:chExt cx="0" cy="0"/>
+        </a:xfrm>
+      </p:grpSpPr>
+      <p:sp>
+        <p:nvSpPr>
+          <p:cNvPr id="3" name="Inhaltsplatzhalter 2"/>
+          <p:cNvSpPr>
+            <a:spLocks noGrp="1"/>
+          </p:cNvSpPr>
+          <p:nvPr>
+            <p:ph sz="half" idx="1" hasCustomPrompt="1"/>
+          </p:nvPr>
+        </p:nvSpPr>
+        <p:spPr>
+          <a:xfrm>
+            <a:off x="462405" y="1344613"/>
+            <a:ext cx="3960000" cy="3859212"/>
+          </a:xfrm>
+        </p:spPr>
+        <p:txBody>
+          <a:bodyPr>
+            <a:normAutofit/>
+          </a:bodyPr>
+          <a:lstStyle>
+            <a:lvl1pPr>
+              <a:defRPr sz="1600"/>
+            </a:lvl1pPr>
+            <a:lvl2pPr marL="541312" indent="-285750">
+              <a:buClr>
+                <a:schemeClr val="accent1"/>
+              </a:buClr>
+              <a:buFont typeface="Wingdings" charset="2"/>
+              <a:buChar char="§"/>
+              <a:defRPr sz="1500"/>
+            </a:lvl2pPr>
+            <a:lvl3pPr>
+              <a:defRPr sz="1400"/>
+            </a:lvl3pPr>
+            <a:lvl4pPr>
+              <a:buClr>
+                <a:schemeClr val="accent1"/>
+              </a:buClr>
+              <a:defRPr sz="1200"/>
+            </a:lvl4pPr>
+            <a:lvl5pPr>
+              <a:defRPr sz="1200"/>
+            </a:lvl5pPr>
+            <a:lvl6pPr>
+              <a:defRPr sz="1800"/>
+            </a:lvl6pPr>
+            <a:lvl7pPr>
+              <a:defRPr sz="1800"/>
+            </a:lvl7pPr>
+            <a:lvl8pPr>
+              <a:defRPr sz="1800"/>
+            </a:lvl8pPr>
+            <a:lvl9pPr>
+              <a:defRPr sz="1800"/>
+            </a:lvl9pPr>
+          </a:lstStyle>
+          <a:p>
+            <a:pPr lvl="0"/>
+            <a:r>
+              <a:rPr lang="en-GB" dirty="0" err="1"/>
+              <a:t>Textmasterformat</a:t>
+            </a:r>
+            <a:r>
+              <a:rPr lang="en-GB" dirty="0"/>
+              <a:t> </a:t>
+            </a:r>
+            <a:r>
+              <a:rPr lang="en-GB" dirty="0" err="1"/>
+              <a:t>bearbeiten</a:t>
+            </a:r>
+            <a:endParaRPr lang="en-GB" dirty="0"/>
+          </a:p>
+          <a:p>
+            <a:pPr lvl="1"/>
+            <a:r>
+              <a:rPr lang="en-GB" dirty="0" err="1"/>
+              <a:t>Zweite</a:t>
+            </a:r>
+            <a:r>
+              <a:rPr lang="en-GB" dirty="0"/>
+              <a:t> </a:t>
+            </a:r>
+            <a:r>
+              <a:rPr lang="en-GB" dirty="0" err="1"/>
+              <a:t>Ebene</a:t>
+            </a:r>
+            <a:endParaRPr lang="en-GB" dirty="0"/>
+          </a:p>
+          <a:p>
+            <a:pPr lvl="2"/>
+            <a:r>
+              <a:rPr lang="en-GB" dirty="0" err="1"/>
+              <a:t>Dritte</a:t>
+            </a:r>
+            <a:r>
+              <a:rPr lang="en-GB" dirty="0"/>
+              <a:t> </a:t>
+            </a:r>
+            <a:r>
+              <a:rPr lang="en-GB" dirty="0" err="1"/>
+              <a:t>Ebene</a:t>
+            </a:r>
+            <a:endParaRPr lang="en-GB" dirty="0"/>
+          </a:p>
+        </p:txBody>
+      </p:sp>
+      <p:sp>
+        <p:nvSpPr>
+          <p:cNvPr id="4" name="Bildplatzhalter 3"/>
+          <p:cNvSpPr>
+            <a:spLocks noGrp="1"/>
+          </p:cNvSpPr>
+          <p:nvPr>
+            <p:ph type="pic" sz="half" idx="2" hasCustomPrompt="1"/>
+          </p:nvPr>
+        </p:nvSpPr>
+        <p:spPr>
+          <a:xfrm>
+            <a:off x="4715688" y="1344613"/>
+            <a:ext cx="3960000" cy="3859212"/>
+          </a:xfrm>
+        </p:spPr>
+        <p:txBody>
+          <a:bodyPr anchor="ctr"/>
+          <a:lstStyle>
+            <a:lvl1pPr marL="0" indent="0" algn="ctr">
+              <a:buNone/>
+              <a:defRPr sz="1200"/>
+            </a:lvl1pPr>
+          </a:lstStyle>
+          <a:p>
+            <a:r>
+              <a:rPr lang="en-GB" dirty="0"/>
+              <a:t>Click icon to add picture</a:t>
+            </a:r>
+          </a:p>
+        </p:txBody>
+      </p:sp>
+      <p:sp>
+        <p:nvSpPr>
+          <p:cNvPr id="20" name="Logoplatzhalter 19"/>
+          <p:cNvSpPr>
+            <a:spLocks noGrp="1"/>
+          </p:cNvSpPr>
+          <p:nvPr>
+            <p:ph type="pic" sz="quarter" idx="13" hasCustomPrompt="1"/>
+          </p:nvPr>
+        </p:nvSpPr>
+        <p:spPr>
+          <a:xfrm>
+            <a:off x="7715688" y="4243825"/>
+            <a:ext cx="860000" cy="860000"/>
+          </a:xfrm>
+        </p:spPr>
+        <p:txBody>
+          <a:bodyPr anchor="ctr"/>
+          <a:lstStyle>
+            <a:lvl1pPr marL="0" indent="0" algn="ctr">
+              <a:buNone/>
+              <a:defRPr sz="1200"/>
+            </a:lvl1pPr>
+          </a:lstStyle>
+          <a:p>
+            <a:r>
+              <a:rPr lang="en-GB" dirty="0"/>
+              <a:t>Logo</a:t>
+            </a:r>
+          </a:p>
+        </p:txBody>
+      </p:sp>
+      <p:sp>
+        <p:nvSpPr>
+          <p:cNvPr id="5" name="Datumsplatzhalter 4"/>
+          <p:cNvSpPr>
+            <a:spLocks noGrp="1"/>
+          </p:cNvSpPr>
+          <p:nvPr>
+            <p:ph type="dt" sz="half" idx="10"/>
+          </p:nvPr>
+        </p:nvSpPr>
+        <p:spPr/>
+        <p:txBody>
+          <a:bodyPr/>
+          <a:lstStyle/>
+          <a:p>
+            <a:fld id="{C2FD44FF-326E-4934-AE8D-65DEFF191BB1}" type="datetime1">
+              <a:rPr lang="en-GB" smtClean="0"/>
+              <a:t>25/08/2023</a:t>
+            </a:fld>
+            <a:endParaRPr lang="en-GB" dirty="0"/>
+          </a:p>
+        </p:txBody>
+      </p:sp>
+      <p:sp>
+        <p:nvSpPr>
+          <p:cNvPr id="9" name="Fußzeilenplatzhalter 8"/>
+          <p:cNvSpPr>
+            <a:spLocks noGrp="1"/>
+          </p:cNvSpPr>
+          <p:nvPr>
+            <p:ph type="ftr" sz="quarter" idx="11"/>
+          </p:nvPr>
+        </p:nvSpPr>
+        <p:spPr/>
+        <p:txBody>
+          <a:bodyPr/>
+          <a:lstStyle/>
+          <a:p>
+            <a:r>
+              <a:rPr lang="en-GB" dirty="0"/>
+              <a:t>Sample Footer</a:t>
+            </a:r>
+          </a:p>
+        </p:txBody>
+      </p:sp>
+      <p:sp>
+        <p:nvSpPr>
+          <p:cNvPr id="10" name="Foliennummernplatzhalter 9"/>
+          <p:cNvSpPr>
+            <a:spLocks noGrp="1"/>
+          </p:cNvSpPr>
+          <p:nvPr>
+            <p:ph type="sldNum" sz="quarter" idx="12"/>
+          </p:nvPr>
+        </p:nvSpPr>
+        <p:spPr/>
+        <p:txBody>
+          <a:bodyPr/>
+          <a:lstStyle/>
+          <a:p>
+            <a:r>
+              <a:rPr lang="en-GB" dirty="0"/>
+              <a:t>Page </a:t>
+            </a:r>
+            <a:fld id="{BE3DC40E-DBBE-4E2D-9EEC-FBF0DA0E9179}" type="slidenum">
+              <a:rPr lang="en-GB" smtClean="0"/>
+              <a:t>‹Nr.›</a:t>
+            </a:fld>
+            <a:endParaRPr lang="en-GB" dirty="0"/>
+          </a:p>
+        </p:txBody>
+      </p:sp>
+      <p:sp>
+        <p:nvSpPr>
+          <p:cNvPr id="2" name="Titel 1"/>
+          <p:cNvSpPr>
+            <a:spLocks noGrp="1"/>
+          </p:cNvSpPr>
+          <p:nvPr>
+            <p:ph type="title"/>
+          </p:nvPr>
+        </p:nvSpPr>
+        <p:spPr/>
+        <p:txBody>
+          <a:bodyPr/>
+          <a:lstStyle/>
+          <a:p>
+            <a:r>
+              <a:rPr lang="de-DE"/>
+              <a:t>Mastertitelformat bearbeiten</a:t>
+            </a:r>
+            <a:endParaRPr lang="en-GB" dirty="0"/>
+          </a:p>
+        </p:txBody>
+      </p:sp>
+    </p:spTree>
+  </p:cSld>
+  <p:clrMapOvr>
+    <a:masterClrMapping/>
+  </p:clrMapOvr>
+  <p:transition>
+    <p:fade/>
+  </p:transition>
+</p:sldLayout>
+</file>
+
+<file path=ppt/slideLayouts/slideLayout18.xml><?xml version="1.0" encoding="utf-8"?>
+<p:sldLayout xmlns:a="http://schemas.openxmlformats.org/drawingml/2006/main" xmlns:r="http://schemas.openxmlformats.org/officeDocument/2006/relationships" xmlns:p="http://schemas.openxmlformats.org/presentationml/2006/main" preserve="1" userDrawn="1">
+  <p:cSld name="Titel und Tabelle">
+    <p:spTree>
+      <p:nvGrpSpPr>
+        <p:cNvPr id="1" name=""/>
+        <p:cNvGrpSpPr/>
+        <p:nvPr/>
+      </p:nvGrpSpPr>
+      <p:grpSpPr>
+        <a:xfrm>
+          <a:off x="0" y="0"/>
+          <a:ext cx="0" cy="0"/>
+          <a:chOff x="0" y="0"/>
+          <a:chExt cx="0" cy="0"/>
+        </a:xfrm>
+      </p:grpSpPr>
+      <p:sp>
+        <p:nvSpPr>
+          <p:cNvPr id="3" name="Inhaltsplatzhalter 2"/>
+          <p:cNvSpPr>
+            <a:spLocks noGrp="1"/>
+          </p:cNvSpPr>
+          <p:nvPr>
+            <p:ph type="tbl" idx="1" hasCustomPrompt="1"/>
+          </p:nvPr>
+        </p:nvSpPr>
+        <p:spPr>
+          <a:xfrm>
+            <a:off x="462019" y="1344613"/>
+            <a:ext cx="7759644" cy="3853905"/>
+          </a:xfrm>
+        </p:spPr>
+        <p:txBody>
+          <a:bodyPr lIns="0" rIns="0">
+            <a:normAutofit/>
+          </a:bodyPr>
+          <a:lstStyle>
+            <a:lvl1pPr>
+              <a:defRPr sz="1600"/>
+            </a:lvl1pPr>
+            <a:lvl2pPr>
+              <a:defRPr sz="1500"/>
+            </a:lvl2pPr>
+            <a:lvl3pPr>
+              <a:defRPr sz="1400"/>
+            </a:lvl3pPr>
+            <a:lvl4pPr>
+              <a:defRPr sz="1200"/>
+            </a:lvl4pPr>
+            <a:lvl5pPr>
+              <a:defRPr sz="1200"/>
+            </a:lvl5pPr>
+          </a:lstStyle>
+          <a:p>
+            <a:pPr marL="0" indent="0">
+              <a:buNone/>
+            </a:pPr>
+            <a:r>
+              <a:rPr lang="en-GB" dirty="0"/>
+              <a:t>Click icon to add table</a:t>
+            </a:r>
+          </a:p>
+        </p:txBody>
+      </p:sp>
+      <p:sp>
+        <p:nvSpPr>
+          <p:cNvPr id="4" name="Datumsplatzhalter 3"/>
+          <p:cNvSpPr>
+            <a:spLocks noGrp="1"/>
+          </p:cNvSpPr>
+          <p:nvPr>
+            <p:ph type="dt" sz="half" idx="10"/>
+          </p:nvPr>
+        </p:nvSpPr>
+        <p:spPr/>
+        <p:txBody>
+          <a:bodyPr/>
+          <a:lstStyle/>
+          <a:p>
+            <a:fld id="{E40E7AAB-A700-485E-A2FB-EAC3CFB07074}" type="datetime1">
+              <a:rPr lang="en-GB" smtClean="0"/>
+              <a:t>25/08/2023</a:t>
+            </a:fld>
+            <a:endParaRPr lang="en-GB" dirty="0"/>
+          </a:p>
+        </p:txBody>
+      </p:sp>
+      <p:sp>
+        <p:nvSpPr>
+          <p:cNvPr id="8" name="Fußzeilenplatzhalter 7"/>
+          <p:cNvSpPr>
+            <a:spLocks noGrp="1"/>
+          </p:cNvSpPr>
+          <p:nvPr>
+            <p:ph type="ftr" sz="quarter" idx="11"/>
+          </p:nvPr>
+        </p:nvSpPr>
+        <p:spPr/>
+        <p:txBody>
+          <a:bodyPr/>
+          <a:lstStyle/>
+          <a:p>
+            <a:r>
+              <a:rPr lang="en-GB" dirty="0"/>
+              <a:t>Sample Footer</a:t>
+            </a:r>
+          </a:p>
+        </p:txBody>
+      </p:sp>
+      <p:sp>
+        <p:nvSpPr>
+          <p:cNvPr id="9" name="Foliennummernplatzhalter 8"/>
+          <p:cNvSpPr>
+            <a:spLocks noGrp="1"/>
+          </p:cNvSpPr>
+          <p:nvPr>
+            <p:ph type="sldNum" sz="quarter" idx="12"/>
+          </p:nvPr>
+        </p:nvSpPr>
+        <p:spPr/>
+        <p:txBody>
+          <a:bodyPr/>
+          <a:lstStyle/>
+          <a:p>
+            <a:r>
+              <a:rPr lang="en-GB" dirty="0"/>
+              <a:t>Page </a:t>
+            </a:r>
+            <a:fld id="{BE3DC40E-DBBE-4E2D-9EEC-FBF0DA0E9179}" type="slidenum">
+              <a:rPr lang="en-GB" smtClean="0"/>
+              <a:t>‹Nr.›</a:t>
+            </a:fld>
+            <a:endParaRPr lang="en-GB" dirty="0"/>
+          </a:p>
+        </p:txBody>
+      </p:sp>
+      <p:sp>
+        <p:nvSpPr>
+          <p:cNvPr id="2" name="Titel 1"/>
+          <p:cNvSpPr>
+            <a:spLocks noGrp="1"/>
+          </p:cNvSpPr>
+          <p:nvPr>
+            <p:ph type="title"/>
+          </p:nvPr>
+        </p:nvSpPr>
+        <p:spPr/>
+        <p:txBody>
+          <a:bodyPr/>
+          <a:lstStyle/>
+          <a:p>
+            <a:r>
+              <a:rPr lang="de-DE"/>
+              <a:t>Mastertitelformat bearbeiten</a:t>
+            </a:r>
+            <a:endParaRPr lang="en-GB" dirty="0"/>
+          </a:p>
+        </p:txBody>
+      </p:sp>
+    </p:spTree>
+  </p:cSld>
+  <p:clrMapOvr>
+    <a:masterClrMapping/>
+  </p:clrMapOvr>
+  <p:transition>
+    <p:fade/>
+  </p:transition>
+</p:sldLayout>
+</file>
+
 <file path=ppt/slideLayouts/slideLayout2.xml><?xml version="1.0" encoding="utf-8"?>
 <p:sldLayout xmlns:a="http://schemas.openxmlformats.org/drawingml/2006/main" xmlns:r="http://schemas.openxmlformats.org/officeDocument/2006/relationships" xmlns:p="http://schemas.openxmlformats.org/presentationml/2006/main" showMasterSp="0" preserve="1" userDrawn="1">
   <p:cSld name="Titelfolie kurz">
@@ -22818,6 +23796,9 @@
     <p:sldLayoutId id="2147483667" r:id="rId13"/>
     <p:sldLayoutId id="2147483668" r:id="rId14"/>
     <p:sldLayoutId id="2147483670" r:id="rId15"/>
+    <p:sldLayoutId id="2147483692" r:id="rId19"/>
+    <p:sldLayoutId id="2147483693" r:id="rId20"/>
+    <p:sldLayoutId id="2147483694" r:id="rId21"/>
   </p:sldLayoutIdLst>
   <p:transition>
     <p:fade/>
@@ -28553,6 +29534,1398 @@
     <p:extLst>
       <p:ext uri="{BB962C8B-B14F-4D97-AF65-F5344CB8AC3E}">
         <p14:creationId xmlns:p14="http://schemas.microsoft.com/office/powerpoint/2010/main" val="1702063927"/>
+      </p:ext>
+    </p:extLst>
+  </p:cSld>
+  <p:clrMapOvr>
+    <a:masterClrMapping/>
+  </p:clrMapOvr>
+  <p:transition>
+    <p:fade/>
+  </p:transition>
+</p:sld>
+</file>
+
+<file path=ppt/slides/slide27.xml><?xml version="1.0" encoding="utf-8"?>
+<p:sld xmlns:a="http://schemas.openxmlformats.org/drawingml/2006/main" xmlns:r="http://schemas.openxmlformats.org/officeDocument/2006/relationships" xmlns:p="http://schemas.openxmlformats.org/presentationml/2006/main">
+  <p:cSld>
+    <p:spTree>
+      <p:nvGrpSpPr>
+        <p:cNvPr id="1" name=""/>
+        <p:cNvGrpSpPr/>
+        <p:nvPr/>
+      </p:nvGrpSpPr>
+      <p:grpSpPr>
+        <a:xfrm>
+          <a:off x="0" y="0"/>
+          <a:ext cx="0" cy="0"/>
+          <a:chOff x="0" y="0"/>
+          <a:chExt cx="0" cy="0"/>
+        </a:xfrm>
+      </p:grpSpPr>
+      <p:sp>
+        <p:nvSpPr>
+          <p:cNvPr id="2" name="Titel 1"/>
+          <p:cNvSpPr>
+            <a:spLocks noGrp="1"/>
+          </p:cNvSpPr>
+          <p:nvPr>
+            <p:ph type="ctrTitle"/>
+          </p:nvPr>
+        </p:nvSpPr>
+        <p:spPr/>
+        <p:txBody>
+          <a:bodyPr/>
+          <a:lstStyle/>
+          <a:p>
+            <a:pPr lvl="0"/>
+            <a:r>
+              <a:rPr lang="en-GB" dirty="0"/>
+              <a:t>Layout „Titelfolie Kontakt“</a:t>
+            </a:r>
+          </a:p>
+        </p:txBody>
+      </p:sp>
+      <p:sp>
+        <p:nvSpPr>
+          <p:cNvPr id="3" name="Untertitel 2"/>
+          <p:cNvSpPr>
+            <a:spLocks noGrp="1"/>
+          </p:cNvSpPr>
+          <p:nvPr>
+            <p:ph type="subTitle" idx="1"/>
+          </p:nvPr>
+        </p:nvSpPr>
+        <p:spPr/>
+        <p:txBody>
+          <a:bodyPr/>
+          <a:lstStyle/>
+          <a:p>
+            <a:pPr lvl="0"/>
+            <a:r>
+              <a:rPr lang="en-GB" dirty="0"/>
+              <a:t>Subtitle of presentation</a:t>
+            </a:r>
+          </a:p>
+        </p:txBody>
+      </p:sp>
+      <p:sp>
+        <p:nvSpPr>
+          <p:cNvPr id="4" name="Textplatzhalter 3"/>
+          <p:cNvSpPr>
+            <a:spLocks noGrp="1"/>
+          </p:cNvSpPr>
+          <p:nvPr>
+            <p:ph type="body" sz="quarter" idx="11"/>
+          </p:nvPr>
+        </p:nvSpPr>
+        <p:spPr/>
+        <p:txBody>
+          <a:bodyPr/>
+          <a:lstStyle/>
+          <a:p>
+            <a:pPr lvl="0"/>
+            <a:r>
+              <a:rPr lang="en-GB" dirty="0"/>
+              <a:t>Name and position</a:t>
+            </a:r>
+          </a:p>
+          <a:p>
+            <a:pPr lvl="0"/>
+            <a:r>
+              <a:rPr lang="en-GB" dirty="0"/>
+              <a:t>Institute</a:t>
+            </a:r>
+          </a:p>
+          <a:p>
+            <a:pPr lvl="0"/>
+            <a:r>
+              <a:rPr lang="en-GB" dirty="0"/>
+              <a:t>name@wu.ac.at</a:t>
+            </a:r>
+          </a:p>
+          <a:p>
+            <a:pPr lvl="0"/>
+            <a:r>
+              <a:rPr lang="en-GB" dirty="0"/>
+              <a:t>Link, e.g. to office hours</a:t>
+            </a:r>
+          </a:p>
+        </p:txBody>
+      </p:sp>
+      <p:sp>
+        <p:nvSpPr>
+          <p:cNvPr id="9" name="Textplatzhalter 8">
+            <a:extLst>
+              <a:ext uri="{FF2B5EF4-FFF2-40B4-BE49-F238E27FC236}">
+                <a16:creationId xmlns:a16="http://schemas.microsoft.com/office/drawing/2014/main" id="{4FBF7533-AD66-42A8-8D36-C2EA127B3006}"/>
+              </a:ext>
+            </a:extLst>
+          </p:cNvPr>
+          <p:cNvSpPr>
+            <a:spLocks noGrp="1"/>
+          </p:cNvSpPr>
+          <p:nvPr>
+            <p:ph type="body" sz="quarter" idx="12"/>
+          </p:nvPr>
+        </p:nvSpPr>
+        <p:spPr/>
+        <p:txBody>
+          <a:bodyPr/>
+          <a:lstStyle/>
+          <a:p>
+            <a:endParaRPr lang="de-AT"/>
+          </a:p>
+        </p:txBody>
+      </p:sp>
+    </p:spTree>
+    <p:extLst>
+      <p:ext uri="{BB962C8B-B14F-4D97-AF65-F5344CB8AC3E}">
+        <p14:creationId xmlns:p14="http://schemas.microsoft.com/office/powerpoint/2010/main" val="4084496989"/>
+      </p:ext>
+    </p:extLst>
+  </p:cSld>
+  <p:clrMapOvr>
+    <a:masterClrMapping/>
+  </p:clrMapOvr>
+  <p:transition>
+    <p:fade/>
+  </p:transition>
+</p:sld>
+</file>
+
+<file path=ppt/slides/slide28.xml><?xml version="1.0" encoding="utf-8"?>
+<p:sld xmlns:a="http://schemas.openxmlformats.org/drawingml/2006/main" xmlns:r="http://schemas.openxmlformats.org/officeDocument/2006/relationships" xmlns:p="http://schemas.openxmlformats.org/presentationml/2006/main">
+  <p:cSld>
+    <p:spTree>
+      <p:nvGrpSpPr>
+        <p:cNvPr id="1" name=""/>
+        <p:cNvGrpSpPr/>
+        <p:nvPr/>
+      </p:nvGrpSpPr>
+      <p:grpSpPr>
+        <a:xfrm>
+          <a:off x="0" y="0"/>
+          <a:ext cx="0" cy="0"/>
+          <a:chOff x="0" y="0"/>
+          <a:chExt cx="0" cy="0"/>
+        </a:xfrm>
+      </p:grpSpPr>
+      <p:sp>
+        <p:nvSpPr>
+          <p:cNvPr id="10" name="Inhaltsplatzhalter 9"/>
+          <p:cNvSpPr>
+            <a:spLocks noGrp="1"/>
+          </p:cNvSpPr>
+          <p:nvPr>
+            <p:ph sz="half" idx="1"/>
+          </p:nvPr>
+        </p:nvSpPr>
+        <p:spPr/>
+        <p:txBody>
+          <a:bodyPr>
+            <a:normAutofit/>
+          </a:bodyPr>
+          <a:lstStyle/>
+          <a:p>
+            <a:pPr lvl="0"/>
+            <a:r>
+              <a:rPr lang="en-GB" dirty="0" sz="1500"/>
+              <a:t>Text on the left, picture on the right</a:t>
+            </a:r>
+          </a:p>
+          <a:p>
+            <a:pPr lvl="1"/>
+            <a:r>
+              <a:rPr lang="en-GB" dirty="0" sz="1500"/>
+              <a:t>Click the icon in the large placeholder to insert a photo; it is cropped to fit</a:t>
+            </a:r>
+          </a:p>
+          <a:p>
+            <a:pPr lvl="1"/>
+            <a:r>
+              <a:rPr lang="en-GB" dirty="0" sz="1500"/>
+              <a:t>The small square placeholder in its corner holds a logo, e.g. of a partner company</a:t>
+            </a:r>
+          </a:p>
+          <a:p>
+            <a:pPr lvl="0"/>
+            <a:r>
+              <a:rPr lang="en-GB" dirty="0" sz="1500"/>
+              <a:t>Use for introducing a company, product or person</a:t>
+            </a:r>
+          </a:p>
+        </p:txBody>
+      </p:sp>
+      <p:pic>
+        <p:nvPicPr>
+          <p:cNvPr id="11" name="Bildplatzhalter 10" descr="Sample photo of a WU building"/>
+          <p:cNvPicPr>
+            <a:picLocks noGrp="1" noChangeAspect="1"/>
+          </p:cNvPicPr>
+          <p:nvPr>
+            <p:ph type="pic" sz="half" idx="2"/>
+          </p:nvPr>
+        </p:nvPicPr>
+        <p:blipFill>
+          <a:blip r:embed="rId2"/>
+          <a:srcRect l="17950" r="17950"/>
+          <a:stretch>
+            <a:fillRect/>
+          </a:stretch>
+        </p:blipFill>
+        <p:spPr/>
+      </p:pic>
+      <p:sp>
+        <p:nvSpPr>
+          <p:cNvPr id="12" name="Logoplatzhalter 11"/>
+          <p:cNvSpPr>
+            <a:spLocks noGrp="1"/>
+          </p:cNvSpPr>
+          <p:nvPr>
+            <p:ph type="pic" sz="quarter" idx="13"/>
+          </p:nvPr>
+        </p:nvSpPr>
+        <p:spPr/>
+      </p:sp>
+      <p:sp>
+        <p:nvSpPr>
+          <p:cNvPr id="5" name="Fußzeilenplatzhalter 4"/>
+          <p:cNvSpPr>
+            <a:spLocks noGrp="1"/>
+          </p:cNvSpPr>
+          <p:nvPr>
+            <p:ph type="ftr" sz="quarter" idx="11"/>
+          </p:nvPr>
+        </p:nvSpPr>
+        <p:spPr/>
+        <p:txBody>
+          <a:bodyPr/>
+          <a:lstStyle/>
+          <a:p>
+            <a:r>
+              <a:rPr lang="en-GB" dirty="0"/>
+              <a:t>Sample Footer</a:t>
+            </a:r>
+          </a:p>
+        </p:txBody>
+      </p:sp>
+      <p:sp>
+        <p:nvSpPr>
+          <p:cNvPr id="6" name="Foliennummernplatzhalter 5"/>
+          <p:cNvSpPr>
+            <a:spLocks noGrp="1"/>
+          </p:cNvSpPr>
+          <p:nvPr>
+            <p:ph type="sldNum" sz="quarter" idx="12"/>
+          </p:nvPr>
+        </p:nvSpPr>
+        <p:spPr/>
+        <p:txBody>
+          <a:bodyPr/>
+          <a:lstStyle/>
+          <a:p>
+            <a:r>
+              <a:rPr lang="en-GB" dirty="0"/>
+              <a:t>Page </a:t>
+            </a:r>
+            <a:fld id="{941D2295-CC7E-4B5B-BFD3-593FD9D32866}" type="slidenum">
+              <a:rPr lang="en-GB" smtClean="0"/>
+              <a:pPr/>
+              <a:t>17</a:t>
+            </a:fld>
+            <a:endParaRPr lang="en-GB" dirty="0"/>
+          </a:p>
+        </p:txBody>
+      </p:sp>
+      <p:sp>
+        <p:nvSpPr>
+          <p:cNvPr id="9" name="Titel 8"/>
+          <p:cNvSpPr>
+            <a:spLocks noGrp="1"/>
+          </p:cNvSpPr>
+          <p:nvPr>
+            <p:ph type="title"/>
+          </p:nvPr>
+        </p:nvSpPr>
+        <p:spPr/>
+        <p:txBody>
+          <a:bodyPr/>
+          <a:lstStyle/>
+          <a:p>
+            <a:pPr lvl="0"/>
+            <a:r>
+              <a:rPr lang="en-GB" dirty="0"/>
+              <a:t>Layout „Inhalt und Bild mit Logo“ – text, picture and logo</a:t>
+            </a:r>
+          </a:p>
+        </p:txBody>
+      </p:sp>
+    </p:spTree>
+    <p:extLst>
+      <p:ext uri="{BB962C8B-B14F-4D97-AF65-F5344CB8AC3E}">
+        <p14:creationId xmlns:p14="http://schemas.microsoft.com/office/powerpoint/2010/main" val="3852802689"/>
+      </p:ext>
+    </p:extLst>
+  </p:cSld>
+  <p:clrMapOvr>
+    <a:masterClrMapping/>
+  </p:clrMapOvr>
+  <p:transition>
+    <p:fade/>
+  </p:transition>
+</p:sld>
+</file>
+
+<file path=ppt/slides/slide29.xml><?xml version="1.0" encoding="utf-8"?>
+<p:sld xmlns:a="http://schemas.openxmlformats.org/drawingml/2006/main" xmlns:r="http://schemas.openxmlformats.org/officeDocument/2006/relationships" xmlns:p="http://schemas.openxmlformats.org/presentationml/2006/main">
+  <p:cSld>
+    <p:spTree>
+      <p:nvGrpSpPr>
+        <p:cNvPr id="1" name=""/>
+        <p:cNvGrpSpPr/>
+        <p:nvPr/>
+      </p:nvGrpSpPr>
+      <p:grpSpPr>
+        <a:xfrm>
+          <a:off x="0" y="0"/>
+          <a:ext cx="0" cy="0"/>
+          <a:chOff x="0" y="0"/>
+          <a:chExt cx="0" cy="0"/>
+        </a:xfrm>
+      </p:grpSpPr>
+      <p:sp>
+        <p:nvSpPr>
+          <p:cNvPr id="5" name="Fußzeilenplatzhalter 4"/>
+          <p:cNvSpPr>
+            <a:spLocks noGrp="1"/>
+          </p:cNvSpPr>
+          <p:nvPr>
+            <p:ph type="ftr" sz="quarter" idx="11"/>
+          </p:nvPr>
+        </p:nvSpPr>
+        <p:spPr/>
+        <p:txBody>
+          <a:bodyPr/>
+          <a:lstStyle/>
+          <a:p>
+            <a:r>
+              <a:rPr lang="en-GB" dirty="0"/>
+              <a:t>Sample Footer</a:t>
+            </a:r>
+          </a:p>
+        </p:txBody>
+      </p:sp>
+      <p:sp>
+        <p:nvSpPr>
+          <p:cNvPr id="4" name="Foliennummernplatzhalter 3"/>
+          <p:cNvSpPr>
+            <a:spLocks noGrp="1"/>
+          </p:cNvSpPr>
+          <p:nvPr>
+            <p:ph type="sldNum" sz="quarter" idx="12"/>
+          </p:nvPr>
+        </p:nvSpPr>
+        <p:spPr/>
+        <p:txBody>
+          <a:bodyPr/>
+          <a:lstStyle/>
+          <a:p>
+            <a:r>
+              <a:rPr lang="en-GB" dirty="0"/>
+              <a:t>Page </a:t>
+            </a:r>
+            <a:fld id="{941D2295-CC7E-4B5B-BFD3-593FD9D32866}" type="slidenum">
+              <a:rPr lang="en-GB" smtClean="0"/>
+              <a:pPr/>
+              <a:t>19</a:t>
+            </a:fld>
+            <a:endParaRPr lang="en-GB" dirty="0"/>
+          </a:p>
+        </p:txBody>
+      </p:sp>
+      <p:sp>
+        <p:nvSpPr>
+          <p:cNvPr id="2" name="Titel 1"/>
+          <p:cNvSpPr>
+            <a:spLocks noGrp="1"/>
+          </p:cNvSpPr>
+          <p:nvPr>
+            <p:ph type="title"/>
+          </p:nvPr>
+        </p:nvSpPr>
+        <p:spPr/>
+        <p:txBody>
+          <a:bodyPr/>
+          <a:lstStyle/>
+          <a:p>
+            <a:pPr lvl="0"/>
+            <a:r>
+              <a:rPr lang="en-GB" dirty="0"/>
+              <a:t>Layout „Titel und Tabelle“ – title with table placeholder</a:t>
+            </a:r>
+          </a:p>
+        </p:txBody>
+      </p:sp>
+      <p:graphicFrame>
+        <p:nvGraphicFramePr>
+          <p:cNvPr id="7" name="Inhaltsplatzhalter 5"/>
+          <p:cNvGraphicFramePr>
+            <a:graphicFrameLocks/>
+          </p:cNvGraphicFramePr>
+          <p:nvPr>
+            <p:extLst>
+              <p:ext uri="{D42A27DB-BD31-4B8C-83A1-F6EECF244321}">
+                <p14:modId xmlns:p14="http://schemas.microsoft.com/office/powerpoint/2010/main" val="2798997025"/>
+              </p:ext>
+            </p:extLst>
+          </p:nvPr>
+        </p:nvGraphicFramePr>
+        <p:xfrm>
+          <a:off x="468313" y="2024055"/>
+          <a:ext cx="8135938" cy="2492217"/>
+        </p:xfrm>
+        <a:graphic>
+          <a:graphicData uri="http://schemas.openxmlformats.org/drawingml/2006/table">
+            <a:tbl>
+              <a:tblPr firstRow="1" bandRow="1">
+                <a:tableStyleId>{5C22544A-7EE6-4342-B048-85BDC9FD1C3A}</a:tableStyleId>
+              </a:tblPr>
+              <a:tblGrid>
+                <a:gridCol w="2746365">
+                  <a:extLst>
+                    <a:ext uri="{9D8B030D-6E8A-4147-A177-3AD203B41FA5}">
+                      <a16:colId xmlns:a16="http://schemas.microsoft.com/office/drawing/2014/main" val="20000"/>
+                    </a:ext>
+                  </a:extLst>
+                </a:gridCol>
+                <a:gridCol w="2643206">
+                  <a:extLst>
+                    <a:ext uri="{9D8B030D-6E8A-4147-A177-3AD203B41FA5}">
+                      <a16:colId xmlns:a16="http://schemas.microsoft.com/office/drawing/2014/main" val="20001"/>
+                    </a:ext>
+                  </a:extLst>
+                </a:gridCol>
+                <a:gridCol w="2746367">
+                  <a:extLst>
+                    <a:ext uri="{9D8B030D-6E8A-4147-A177-3AD203B41FA5}">
+                      <a16:colId xmlns:a16="http://schemas.microsoft.com/office/drawing/2014/main" val="20002"/>
+                    </a:ext>
+                  </a:extLst>
+                </a:gridCol>
+              </a:tblGrid>
+              <a:tr h="356031">
+                <a:tc>
+                  <a:txBody>
+                    <a:bodyPr/>
+                    <a:lstStyle/>
+                    <a:p>
+                      <a:r>
+                        <a:rPr lang="en-GB" sz="1500" dirty="0"/>
+                        <a:t>Table header</a:t>
+                      </a:r>
+                    </a:p>
+                  </a:txBody>
+                  <a:tcPr marT="38100" marB="38100"/>
+                </a:tc>
+                <a:tc>
+                  <a:txBody>
+                    <a:bodyPr/>
+                    <a:lstStyle/>
+                    <a:p>
+                      <a:r>
+                        <a:rPr lang="en-GB" sz="1500" dirty="0"/>
+                        <a:t>Sample text 1</a:t>
+                      </a:r>
+                    </a:p>
+                  </a:txBody>
+                  <a:tcPr marT="38100" marB="38100"/>
+                </a:tc>
+                <a:tc>
+                  <a:txBody>
+                    <a:bodyPr/>
+                    <a:lstStyle/>
+                    <a:p>
+                      <a:r>
+                        <a:rPr lang="en-GB" sz="1500" dirty="0"/>
+                        <a:t>Sample text 2</a:t>
+                      </a:r>
+                    </a:p>
+                  </a:txBody>
+                  <a:tcPr marT="38100" marB="38100"/>
+                </a:tc>
+                <a:extLst>
+                  <a:ext uri="{0D108BD9-81ED-4DB2-BD59-A6C34878D82A}">
+                    <a16:rowId xmlns:a16="http://schemas.microsoft.com/office/drawing/2014/main" val="10000"/>
+                  </a:ext>
+                </a:extLst>
+              </a:tr>
+              <a:tr h="356031">
+                <a:tc>
+                  <a:txBody>
+                    <a:bodyPr/>
+                    <a:lstStyle/>
+                    <a:p>
+                      <a:pPr marL="0" marR="0" lvl="0" indent="0" algn="l" defTabSz="914306" rtl="0" eaLnBrk="1" fontAlgn="auto" latinLnBrk="0" hangingPunct="1">
+                        <a:lnSpc>
+                          <a:spcPct val="100000"/>
+                        </a:lnSpc>
+                        <a:spcBef>
+                          <a:spcPts val="0"/>
+                        </a:spcBef>
+                        <a:spcAft>
+                          <a:spcPts val="0"/>
+                        </a:spcAft>
+                        <a:buClrTx/>
+                        <a:buSzTx/>
+                        <a:buFontTx/>
+                        <a:buNone/>
+                        <a:tabLst/>
+                        <a:defRPr/>
+                      </a:pPr>
+                      <a:r>
+                        <a:rPr kumimoji="0" lang="en-GB" sz="1400" u="none" strike="noStrike" cap="none" normalizeH="0" baseline="0" dirty="0">
+                          <a:ln>
+                            <a:noFill/>
+                          </a:ln>
+                          <a:effectLst/>
+                        </a:rPr>
+                        <a:t>Sample text Column 1</a:t>
+                      </a:r>
+                      <a:endParaRPr kumimoji="0" lang="en-GB" sz="1400" b="1" i="0" u="none" strike="noStrike" cap="none" normalizeH="0" baseline="0" dirty="0">
+                        <a:ln>
+                          <a:noFill/>
+                        </a:ln>
+                        <a:solidFill>
+                          <a:srgbClr val="000066"/>
+                        </a:solidFill>
+                        <a:effectLst/>
+                        <a:latin typeface="Verdana" pitchFamily="34" charset="0"/>
+                      </a:endParaRPr>
+                    </a:p>
+                  </a:txBody>
+                  <a:tcPr marT="38100" marB="38100"/>
+                </a:tc>
+                <a:tc>
+                  <a:txBody>
+                    <a:bodyPr/>
+                    <a:lstStyle/>
+                    <a:p>
+                      <a:pPr marL="0" marR="0" lvl="0" indent="0" algn="l" defTabSz="914400" rtl="0" eaLnBrk="1" fontAlgn="auto" latinLnBrk="0" hangingPunct="1">
+                        <a:lnSpc>
+                          <a:spcPct val="100000"/>
+                        </a:lnSpc>
+                        <a:spcBef>
+                          <a:spcPts val="0"/>
+                        </a:spcBef>
+                        <a:spcAft>
+                          <a:spcPts val="0"/>
+                        </a:spcAft>
+                        <a:buClrTx/>
+                        <a:buSzTx/>
+                        <a:buFontTx/>
+                        <a:buNone/>
+                        <a:tabLst/>
+                        <a:defRPr/>
+                      </a:pPr>
+                      <a:r>
+                        <a:rPr kumimoji="0" lang="en-GB" sz="1400" u="none" strike="noStrike" cap="none" normalizeH="0" baseline="0" dirty="0">
+                          <a:ln>
+                            <a:noFill/>
+                          </a:ln>
+                          <a:effectLst/>
+                        </a:rPr>
+                        <a:t>Sample text Column 2</a:t>
+                      </a:r>
+                      <a:endParaRPr kumimoji="0" lang="en-GB" sz="1400" b="1" i="0" u="none" strike="noStrike" cap="none" normalizeH="0" baseline="0" dirty="0">
+                        <a:ln>
+                          <a:noFill/>
+                        </a:ln>
+                        <a:solidFill>
+                          <a:srgbClr val="000066"/>
+                        </a:solidFill>
+                        <a:effectLst/>
+                        <a:latin typeface="Verdana" pitchFamily="34" charset="0"/>
+                      </a:endParaRPr>
+                    </a:p>
+                  </a:txBody>
+                  <a:tcPr marT="38100" marB="38100"/>
+                </a:tc>
+                <a:tc>
+                  <a:txBody>
+                    <a:bodyPr/>
+                    <a:lstStyle/>
+                    <a:p>
+                      <a:pPr marL="0" marR="0" lvl="0" indent="0" algn="l" defTabSz="914400" rtl="0" eaLnBrk="1" fontAlgn="auto" latinLnBrk="0" hangingPunct="1">
+                        <a:lnSpc>
+                          <a:spcPct val="100000"/>
+                        </a:lnSpc>
+                        <a:spcBef>
+                          <a:spcPts val="0"/>
+                        </a:spcBef>
+                        <a:spcAft>
+                          <a:spcPts val="0"/>
+                        </a:spcAft>
+                        <a:buClrTx/>
+                        <a:buSzTx/>
+                        <a:buFontTx/>
+                        <a:buNone/>
+                        <a:tabLst/>
+                        <a:defRPr/>
+                      </a:pPr>
+                      <a:r>
+                        <a:rPr kumimoji="0" lang="en-GB" sz="1400" u="none" strike="noStrike" cap="none" normalizeH="0" baseline="0" dirty="0">
+                          <a:ln>
+                            <a:noFill/>
+                          </a:ln>
+                          <a:effectLst/>
+                        </a:rPr>
+                        <a:t>Sample text Column 3</a:t>
+                      </a:r>
+                      <a:endParaRPr kumimoji="0" lang="en-GB" sz="1400" b="1" i="0" u="none" strike="noStrike" cap="none" normalizeH="0" baseline="0" dirty="0">
+                        <a:ln>
+                          <a:noFill/>
+                        </a:ln>
+                        <a:solidFill>
+                          <a:srgbClr val="000066"/>
+                        </a:solidFill>
+                        <a:effectLst/>
+                        <a:latin typeface="Verdana" pitchFamily="34" charset="0"/>
+                      </a:endParaRPr>
+                    </a:p>
+                  </a:txBody>
+                  <a:tcPr marT="38100" marB="38100"/>
+                </a:tc>
+                <a:extLst>
+                  <a:ext uri="{0D108BD9-81ED-4DB2-BD59-A6C34878D82A}">
+                    <a16:rowId xmlns:a16="http://schemas.microsoft.com/office/drawing/2014/main" val="10001"/>
+                  </a:ext>
+                </a:extLst>
+              </a:tr>
+              <a:tr h="356031">
+                <a:tc>
+                  <a:txBody>
+                    <a:bodyPr/>
+                    <a:lstStyle/>
+                    <a:p>
+                      <a:pPr marL="0" marR="0" lvl="0" indent="0" algn="l" defTabSz="914400" rtl="0" eaLnBrk="1" fontAlgn="auto" latinLnBrk="0" hangingPunct="1">
+                        <a:lnSpc>
+                          <a:spcPct val="100000"/>
+                        </a:lnSpc>
+                        <a:spcBef>
+                          <a:spcPts val="0"/>
+                        </a:spcBef>
+                        <a:spcAft>
+                          <a:spcPts val="0"/>
+                        </a:spcAft>
+                        <a:buClrTx/>
+                        <a:buSzTx/>
+                        <a:buFontTx/>
+                        <a:buNone/>
+                        <a:tabLst/>
+                        <a:defRPr/>
+                      </a:pPr>
+                      <a:r>
+                        <a:rPr kumimoji="0" lang="en-GB" sz="1400" u="none" strike="noStrike" cap="none" normalizeH="0" baseline="0" dirty="0">
+                          <a:ln>
+                            <a:noFill/>
+                          </a:ln>
+                          <a:effectLst/>
+                        </a:rPr>
+                        <a:t>Sample text Column 1</a:t>
+                      </a:r>
+                      <a:endParaRPr kumimoji="0" lang="en-GB" sz="1400" b="1" i="0" u="none" strike="noStrike" cap="none" normalizeH="0" baseline="0" dirty="0">
+                        <a:ln>
+                          <a:noFill/>
+                        </a:ln>
+                        <a:solidFill>
+                          <a:srgbClr val="000066"/>
+                        </a:solidFill>
+                        <a:effectLst/>
+                        <a:latin typeface="Verdana" pitchFamily="34" charset="0"/>
+                      </a:endParaRPr>
+                    </a:p>
+                  </a:txBody>
+                  <a:tcPr marT="38100" marB="38100"/>
+                </a:tc>
+                <a:tc>
+                  <a:txBody>
+                    <a:bodyPr/>
+                    <a:lstStyle/>
+                    <a:p>
+                      <a:pPr marL="0" marR="0" lvl="0" indent="0" algn="l" defTabSz="914400" rtl="0" eaLnBrk="1" fontAlgn="auto" latinLnBrk="0" hangingPunct="1">
+                        <a:lnSpc>
+                          <a:spcPct val="100000"/>
+                        </a:lnSpc>
+                        <a:spcBef>
+                          <a:spcPts val="0"/>
+                        </a:spcBef>
+                        <a:spcAft>
+                          <a:spcPts val="0"/>
+                        </a:spcAft>
+                        <a:buClrTx/>
+                        <a:buSzTx/>
+                        <a:buFontTx/>
+                        <a:buNone/>
+                        <a:tabLst/>
+                        <a:defRPr/>
+                      </a:pPr>
+                      <a:r>
+                        <a:rPr kumimoji="0" lang="en-GB" sz="1400" u="none" strike="noStrike" cap="none" normalizeH="0" baseline="0" dirty="0">
+                          <a:ln>
+                            <a:noFill/>
+                          </a:ln>
+                          <a:effectLst/>
+                        </a:rPr>
+                        <a:t>Sample text Column 2</a:t>
+                      </a:r>
+                      <a:endParaRPr kumimoji="0" lang="en-GB" sz="1400" b="1" i="0" u="none" strike="noStrike" cap="none" normalizeH="0" baseline="0" dirty="0">
+                        <a:ln>
+                          <a:noFill/>
+                        </a:ln>
+                        <a:solidFill>
+                          <a:srgbClr val="000066"/>
+                        </a:solidFill>
+                        <a:effectLst/>
+                        <a:latin typeface="Verdana" pitchFamily="34" charset="0"/>
+                      </a:endParaRPr>
+                    </a:p>
+                  </a:txBody>
+                  <a:tcPr marT="38100" marB="38100"/>
+                </a:tc>
+                <a:tc>
+                  <a:txBody>
+                    <a:bodyPr/>
+                    <a:lstStyle/>
+                    <a:p>
+                      <a:pPr marL="0" marR="0" lvl="0" indent="0" algn="l" defTabSz="914400" rtl="0" eaLnBrk="1" fontAlgn="auto" latinLnBrk="0" hangingPunct="1">
+                        <a:lnSpc>
+                          <a:spcPct val="100000"/>
+                        </a:lnSpc>
+                        <a:spcBef>
+                          <a:spcPts val="0"/>
+                        </a:spcBef>
+                        <a:spcAft>
+                          <a:spcPts val="0"/>
+                        </a:spcAft>
+                        <a:buClrTx/>
+                        <a:buSzTx/>
+                        <a:buFontTx/>
+                        <a:buNone/>
+                        <a:tabLst/>
+                        <a:defRPr/>
+                      </a:pPr>
+                      <a:r>
+                        <a:rPr kumimoji="0" lang="en-GB" sz="1400" u="none" strike="noStrike" cap="none" normalizeH="0" baseline="0" dirty="0">
+                          <a:ln>
+                            <a:noFill/>
+                          </a:ln>
+                          <a:effectLst/>
+                        </a:rPr>
+                        <a:t>Sample text Column 3</a:t>
+                      </a:r>
+                      <a:endParaRPr kumimoji="0" lang="en-GB" sz="1400" b="1" i="0" u="none" strike="noStrike" cap="none" normalizeH="0" baseline="0" dirty="0">
+                        <a:ln>
+                          <a:noFill/>
+                        </a:ln>
+                        <a:solidFill>
+                          <a:srgbClr val="000066"/>
+                        </a:solidFill>
+                        <a:effectLst/>
+                        <a:latin typeface="Verdana" pitchFamily="34" charset="0"/>
+                      </a:endParaRPr>
+                    </a:p>
+                  </a:txBody>
+                  <a:tcPr marT="38100" marB="38100"/>
+                </a:tc>
+                <a:extLst>
+                  <a:ext uri="{0D108BD9-81ED-4DB2-BD59-A6C34878D82A}">
+                    <a16:rowId xmlns:a16="http://schemas.microsoft.com/office/drawing/2014/main" val="10002"/>
+                  </a:ext>
+                </a:extLst>
+              </a:tr>
+              <a:tr h="356031">
+                <a:tc>
+                  <a:txBody>
+                    <a:bodyPr/>
+                    <a:lstStyle/>
+                    <a:p>
+                      <a:pPr marL="0" marR="0" lvl="0" indent="0" algn="l" defTabSz="914400" rtl="0" eaLnBrk="1" fontAlgn="auto" latinLnBrk="0" hangingPunct="1">
+                        <a:lnSpc>
+                          <a:spcPct val="100000"/>
+                        </a:lnSpc>
+                        <a:spcBef>
+                          <a:spcPts val="0"/>
+                        </a:spcBef>
+                        <a:spcAft>
+                          <a:spcPts val="0"/>
+                        </a:spcAft>
+                        <a:buClrTx/>
+                        <a:buSzTx/>
+                        <a:buFontTx/>
+                        <a:buNone/>
+                        <a:tabLst/>
+                        <a:defRPr/>
+                      </a:pPr>
+                      <a:r>
+                        <a:rPr kumimoji="0" lang="en-GB" sz="1400" u="none" strike="noStrike" cap="none" normalizeH="0" baseline="0" dirty="0">
+                          <a:ln>
+                            <a:noFill/>
+                          </a:ln>
+                          <a:effectLst/>
+                        </a:rPr>
+                        <a:t>Sample text Column 1</a:t>
+                      </a:r>
+                      <a:endParaRPr kumimoji="0" lang="en-GB" sz="1400" b="1" i="0" u="none" strike="noStrike" cap="none" normalizeH="0" baseline="0" dirty="0">
+                        <a:ln>
+                          <a:noFill/>
+                        </a:ln>
+                        <a:solidFill>
+                          <a:srgbClr val="000066"/>
+                        </a:solidFill>
+                        <a:effectLst/>
+                        <a:latin typeface="Verdana" pitchFamily="34" charset="0"/>
+                      </a:endParaRPr>
+                    </a:p>
+                  </a:txBody>
+                  <a:tcPr marT="38100" marB="38100"/>
+                </a:tc>
+                <a:tc>
+                  <a:txBody>
+                    <a:bodyPr/>
+                    <a:lstStyle/>
+                    <a:p>
+                      <a:pPr marL="0" marR="0" lvl="0" indent="0" algn="l" defTabSz="914400" rtl="0" eaLnBrk="1" fontAlgn="auto" latinLnBrk="0" hangingPunct="1">
+                        <a:lnSpc>
+                          <a:spcPct val="100000"/>
+                        </a:lnSpc>
+                        <a:spcBef>
+                          <a:spcPts val="0"/>
+                        </a:spcBef>
+                        <a:spcAft>
+                          <a:spcPts val="0"/>
+                        </a:spcAft>
+                        <a:buClrTx/>
+                        <a:buSzTx/>
+                        <a:buFontTx/>
+                        <a:buNone/>
+                        <a:tabLst/>
+                        <a:defRPr/>
+                      </a:pPr>
+                      <a:r>
+                        <a:rPr kumimoji="0" lang="en-GB" sz="1400" u="none" strike="noStrike" cap="none" normalizeH="0" baseline="0" dirty="0">
+                          <a:ln>
+                            <a:noFill/>
+                          </a:ln>
+                          <a:effectLst/>
+                        </a:rPr>
+                        <a:t>Sample text Column 2</a:t>
+                      </a:r>
+                      <a:endParaRPr kumimoji="0" lang="en-GB" sz="1400" b="1" i="0" u="none" strike="noStrike" cap="none" normalizeH="0" baseline="0" dirty="0">
+                        <a:ln>
+                          <a:noFill/>
+                        </a:ln>
+                        <a:solidFill>
+                          <a:srgbClr val="000066"/>
+                        </a:solidFill>
+                        <a:effectLst/>
+                        <a:latin typeface="Verdana" pitchFamily="34" charset="0"/>
+                      </a:endParaRPr>
+                    </a:p>
+                  </a:txBody>
+                  <a:tcPr marT="38100" marB="38100"/>
+                </a:tc>
+                <a:tc>
+                  <a:txBody>
+                    <a:bodyPr/>
+                    <a:lstStyle/>
+                    <a:p>
+                      <a:pPr marL="0" marR="0" lvl="0" indent="0" algn="l" defTabSz="914400" rtl="0" eaLnBrk="1" fontAlgn="auto" latinLnBrk="0" hangingPunct="1">
+                        <a:lnSpc>
+                          <a:spcPct val="100000"/>
+                        </a:lnSpc>
+                        <a:spcBef>
+                          <a:spcPts val="0"/>
+                        </a:spcBef>
+                        <a:spcAft>
+                          <a:spcPts val="0"/>
+                        </a:spcAft>
+                        <a:buClrTx/>
+                        <a:buSzTx/>
+                        <a:buFontTx/>
+                        <a:buNone/>
+                        <a:tabLst/>
+                        <a:defRPr/>
+                      </a:pPr>
+                      <a:r>
+                        <a:rPr kumimoji="0" lang="en-GB" sz="1400" u="none" strike="noStrike" cap="none" normalizeH="0" baseline="0" dirty="0">
+                          <a:ln>
+                            <a:noFill/>
+                          </a:ln>
+                          <a:effectLst/>
+                        </a:rPr>
+                        <a:t>Sample text Column 3</a:t>
+                      </a:r>
+                      <a:endParaRPr kumimoji="0" lang="en-GB" sz="1400" b="1" i="0" u="none" strike="noStrike" cap="none" normalizeH="0" baseline="0" dirty="0">
+                        <a:ln>
+                          <a:noFill/>
+                        </a:ln>
+                        <a:solidFill>
+                          <a:srgbClr val="000066"/>
+                        </a:solidFill>
+                        <a:effectLst/>
+                        <a:latin typeface="Verdana" pitchFamily="34" charset="0"/>
+                      </a:endParaRPr>
+                    </a:p>
+                  </a:txBody>
+                  <a:tcPr marT="38100" marB="38100"/>
+                </a:tc>
+                <a:extLst>
+                  <a:ext uri="{0D108BD9-81ED-4DB2-BD59-A6C34878D82A}">
+                    <a16:rowId xmlns:a16="http://schemas.microsoft.com/office/drawing/2014/main" val="10003"/>
+                  </a:ext>
+                </a:extLst>
+              </a:tr>
+              <a:tr h="356031">
+                <a:tc>
+                  <a:txBody>
+                    <a:bodyPr/>
+                    <a:lstStyle/>
+                    <a:p>
+                      <a:pPr marL="0" marR="0" lvl="0" indent="0" algn="l" defTabSz="914400" rtl="0" eaLnBrk="1" fontAlgn="auto" latinLnBrk="0" hangingPunct="1">
+                        <a:lnSpc>
+                          <a:spcPct val="100000"/>
+                        </a:lnSpc>
+                        <a:spcBef>
+                          <a:spcPts val="0"/>
+                        </a:spcBef>
+                        <a:spcAft>
+                          <a:spcPts val="0"/>
+                        </a:spcAft>
+                        <a:buClrTx/>
+                        <a:buSzTx/>
+                        <a:buFontTx/>
+                        <a:buNone/>
+                        <a:tabLst/>
+                        <a:defRPr/>
+                      </a:pPr>
+                      <a:r>
+                        <a:rPr kumimoji="0" lang="en-GB" sz="1400" u="none" strike="noStrike" cap="none" normalizeH="0" baseline="0" dirty="0">
+                          <a:ln>
+                            <a:noFill/>
+                          </a:ln>
+                          <a:effectLst/>
+                        </a:rPr>
+                        <a:t>Sample text Column 1</a:t>
+                      </a:r>
+                      <a:endParaRPr kumimoji="0" lang="en-GB" sz="1400" b="1" i="0" u="none" strike="noStrike" cap="none" normalizeH="0" baseline="0" dirty="0">
+                        <a:ln>
+                          <a:noFill/>
+                        </a:ln>
+                        <a:solidFill>
+                          <a:srgbClr val="000066"/>
+                        </a:solidFill>
+                        <a:effectLst/>
+                        <a:latin typeface="Verdana" pitchFamily="34" charset="0"/>
+                      </a:endParaRPr>
+                    </a:p>
+                  </a:txBody>
+                  <a:tcPr marT="38100" marB="38100"/>
+                </a:tc>
+                <a:tc>
+                  <a:txBody>
+                    <a:bodyPr/>
+                    <a:lstStyle/>
+                    <a:p>
+                      <a:pPr marL="0" marR="0" lvl="0" indent="0" algn="l" defTabSz="914400" rtl="0" eaLnBrk="1" fontAlgn="auto" latinLnBrk="0" hangingPunct="1">
+                        <a:lnSpc>
+                          <a:spcPct val="100000"/>
+                        </a:lnSpc>
+                        <a:spcBef>
+                          <a:spcPts val="0"/>
+                        </a:spcBef>
+                        <a:spcAft>
+                          <a:spcPts val="0"/>
+                        </a:spcAft>
+                        <a:buClrTx/>
+                        <a:buSzTx/>
+                        <a:buFontTx/>
+                        <a:buNone/>
+                        <a:tabLst/>
+                        <a:defRPr/>
+                      </a:pPr>
+                      <a:r>
+                        <a:rPr kumimoji="0" lang="en-GB" sz="1400" u="none" strike="noStrike" cap="none" normalizeH="0" baseline="0" dirty="0">
+                          <a:ln>
+                            <a:noFill/>
+                          </a:ln>
+                          <a:effectLst/>
+                        </a:rPr>
+                        <a:t>Sample text Column 2</a:t>
+                      </a:r>
+                      <a:endParaRPr kumimoji="0" lang="en-GB" sz="1400" b="1" i="0" u="none" strike="noStrike" cap="none" normalizeH="0" baseline="0" dirty="0">
+                        <a:ln>
+                          <a:noFill/>
+                        </a:ln>
+                        <a:solidFill>
+                          <a:srgbClr val="000066"/>
+                        </a:solidFill>
+                        <a:effectLst/>
+                        <a:latin typeface="Verdana" pitchFamily="34" charset="0"/>
+                      </a:endParaRPr>
+                    </a:p>
+                  </a:txBody>
+                  <a:tcPr marT="38100" marB="38100"/>
+                </a:tc>
+                <a:tc>
+                  <a:txBody>
+                    <a:bodyPr/>
+                    <a:lstStyle/>
+                    <a:p>
+                      <a:pPr marL="0" marR="0" lvl="0" indent="0" algn="l" defTabSz="914400" rtl="0" eaLnBrk="1" fontAlgn="auto" latinLnBrk="0" hangingPunct="1">
+                        <a:lnSpc>
+                          <a:spcPct val="100000"/>
+                        </a:lnSpc>
+                        <a:spcBef>
+                          <a:spcPts val="0"/>
+                        </a:spcBef>
+                        <a:spcAft>
+                          <a:spcPts val="0"/>
+                        </a:spcAft>
+                        <a:buClrTx/>
+                        <a:buSzTx/>
+                        <a:buFontTx/>
+                        <a:buNone/>
+                        <a:tabLst/>
+                        <a:defRPr/>
+                      </a:pPr>
+                      <a:r>
+                        <a:rPr kumimoji="0" lang="en-GB" sz="1400" u="none" strike="noStrike" cap="none" normalizeH="0" baseline="0" dirty="0">
+                          <a:ln>
+                            <a:noFill/>
+                          </a:ln>
+                          <a:effectLst/>
+                        </a:rPr>
+                        <a:t>Sample text Column 3</a:t>
+                      </a:r>
+                      <a:endParaRPr kumimoji="0" lang="en-GB" sz="1400" b="1" i="0" u="none" strike="noStrike" cap="none" normalizeH="0" baseline="0" dirty="0">
+                        <a:ln>
+                          <a:noFill/>
+                        </a:ln>
+                        <a:solidFill>
+                          <a:srgbClr val="000066"/>
+                        </a:solidFill>
+                        <a:effectLst/>
+                        <a:latin typeface="Verdana" pitchFamily="34" charset="0"/>
+                      </a:endParaRPr>
+                    </a:p>
+                  </a:txBody>
+                  <a:tcPr marT="38100" marB="38100"/>
+                </a:tc>
+                <a:extLst>
+                  <a:ext uri="{0D108BD9-81ED-4DB2-BD59-A6C34878D82A}">
+                    <a16:rowId xmlns:a16="http://schemas.microsoft.com/office/drawing/2014/main" val="10004"/>
+                  </a:ext>
+                </a:extLst>
+              </a:tr>
+              <a:tr h="356031">
+                <a:tc>
+                  <a:txBody>
+                    <a:bodyPr/>
+                    <a:lstStyle/>
+                    <a:p>
+                      <a:pPr marL="0" marR="0" lvl="0" indent="0" algn="l" defTabSz="914400" rtl="0" eaLnBrk="1" fontAlgn="auto" latinLnBrk="0" hangingPunct="1">
+                        <a:lnSpc>
+                          <a:spcPct val="100000"/>
+                        </a:lnSpc>
+                        <a:spcBef>
+                          <a:spcPts val="0"/>
+                        </a:spcBef>
+                        <a:spcAft>
+                          <a:spcPts val="0"/>
+                        </a:spcAft>
+                        <a:buClrTx/>
+                        <a:buSzTx/>
+                        <a:buFontTx/>
+                        <a:buNone/>
+                        <a:tabLst/>
+                        <a:defRPr/>
+                      </a:pPr>
+                      <a:r>
+                        <a:rPr kumimoji="0" lang="en-GB" sz="1400" u="none" strike="noStrike" cap="none" normalizeH="0" baseline="0" dirty="0">
+                          <a:ln>
+                            <a:noFill/>
+                          </a:ln>
+                          <a:effectLst/>
+                        </a:rPr>
+                        <a:t>Sample text Column 1</a:t>
+                      </a:r>
+                      <a:endParaRPr kumimoji="0" lang="en-GB" sz="1400" b="1" i="0" u="none" strike="noStrike" cap="none" normalizeH="0" baseline="0" dirty="0">
+                        <a:ln>
+                          <a:noFill/>
+                        </a:ln>
+                        <a:solidFill>
+                          <a:srgbClr val="000066"/>
+                        </a:solidFill>
+                        <a:effectLst/>
+                        <a:latin typeface="Verdana" pitchFamily="34" charset="0"/>
+                      </a:endParaRPr>
+                    </a:p>
+                  </a:txBody>
+                  <a:tcPr marT="38100" marB="38100"/>
+                </a:tc>
+                <a:tc>
+                  <a:txBody>
+                    <a:bodyPr/>
+                    <a:lstStyle/>
+                    <a:p>
+                      <a:pPr marL="0" marR="0" lvl="0" indent="0" algn="l" defTabSz="914400" rtl="0" eaLnBrk="1" fontAlgn="base" latinLnBrk="0" hangingPunct="1">
+                        <a:lnSpc>
+                          <a:spcPct val="100000"/>
+                        </a:lnSpc>
+                        <a:spcBef>
+                          <a:spcPct val="0"/>
+                        </a:spcBef>
+                        <a:spcAft>
+                          <a:spcPct val="0"/>
+                        </a:spcAft>
+                        <a:buClr>
+                          <a:schemeClr val="bg2"/>
+                        </a:buClr>
+                        <a:buSzTx/>
+                        <a:buFontTx/>
+                        <a:buNone/>
+                        <a:tabLst/>
+                        <a:defRPr/>
+                      </a:pPr>
+                      <a:r>
+                        <a:rPr kumimoji="0" lang="en-GB" sz="1400" u="none" strike="noStrike" cap="none" normalizeH="0" baseline="0" dirty="0">
+                          <a:ln>
+                            <a:noFill/>
+                          </a:ln>
+                          <a:effectLst/>
+                        </a:rPr>
+                        <a:t>Sample text Column 2</a:t>
+                      </a:r>
+                      <a:endParaRPr kumimoji="0" lang="en-GB" sz="1400" b="1" i="0" u="none" strike="noStrike" cap="none" normalizeH="0" baseline="0" dirty="0">
+                        <a:ln>
+                          <a:noFill/>
+                        </a:ln>
+                        <a:solidFill>
+                          <a:srgbClr val="000066"/>
+                        </a:solidFill>
+                        <a:effectLst/>
+                        <a:latin typeface="Verdana" pitchFamily="34" charset="0"/>
+                      </a:endParaRPr>
+                    </a:p>
+                  </a:txBody>
+                  <a:tcPr marT="38100" marB="38100"/>
+                </a:tc>
+                <a:tc>
+                  <a:txBody>
+                    <a:bodyPr/>
+                    <a:lstStyle/>
+                    <a:p>
+                      <a:pPr marL="0" marR="0" lvl="0" indent="0" algn="l" defTabSz="914400" rtl="0" eaLnBrk="1" fontAlgn="base" latinLnBrk="0" hangingPunct="1">
+                        <a:lnSpc>
+                          <a:spcPct val="100000"/>
+                        </a:lnSpc>
+                        <a:spcBef>
+                          <a:spcPct val="0"/>
+                        </a:spcBef>
+                        <a:spcAft>
+                          <a:spcPct val="0"/>
+                        </a:spcAft>
+                        <a:buClr>
+                          <a:schemeClr val="bg2"/>
+                        </a:buClr>
+                        <a:buSzTx/>
+                        <a:buFontTx/>
+                        <a:buNone/>
+                        <a:tabLst/>
+                      </a:pPr>
+                      <a:r>
+                        <a:rPr kumimoji="0" lang="en-GB" sz="1400" u="none" strike="noStrike" cap="none" normalizeH="0" baseline="0" dirty="0">
+                          <a:ln>
+                            <a:noFill/>
+                          </a:ln>
+                          <a:effectLst/>
+                        </a:rPr>
+                        <a:t>Sample text Column 3</a:t>
+                      </a:r>
+                      <a:endParaRPr kumimoji="0" lang="en-GB" sz="1400" b="1" i="0" u="none" strike="noStrike" cap="none" normalizeH="0" baseline="0" dirty="0">
+                        <a:ln>
+                          <a:noFill/>
+                        </a:ln>
+                        <a:solidFill>
+                          <a:srgbClr val="000066"/>
+                        </a:solidFill>
+                        <a:effectLst/>
+                        <a:latin typeface="Verdana" pitchFamily="34" charset="0"/>
+                      </a:endParaRPr>
+                    </a:p>
+                  </a:txBody>
+                  <a:tcPr marT="38100" marB="38100"/>
+                </a:tc>
+                <a:extLst>
+                  <a:ext uri="{0D108BD9-81ED-4DB2-BD59-A6C34878D82A}">
+                    <a16:rowId xmlns:a16="http://schemas.microsoft.com/office/drawing/2014/main" val="10005"/>
+                  </a:ext>
+                </a:extLst>
+              </a:tr>
+              <a:tr h="356031">
+                <a:tc>
+                  <a:txBody>
+                    <a:bodyPr/>
+                    <a:lstStyle/>
+                    <a:p>
+                      <a:pPr marL="0" marR="0" lvl="0" indent="0" algn="l" defTabSz="914400" rtl="0" eaLnBrk="1" fontAlgn="auto" latinLnBrk="0" hangingPunct="1">
+                        <a:lnSpc>
+                          <a:spcPct val="100000"/>
+                        </a:lnSpc>
+                        <a:spcBef>
+                          <a:spcPts val="0"/>
+                        </a:spcBef>
+                        <a:spcAft>
+                          <a:spcPts val="0"/>
+                        </a:spcAft>
+                        <a:buClrTx/>
+                        <a:buSzTx/>
+                        <a:buFontTx/>
+                        <a:buNone/>
+                        <a:tabLst/>
+                        <a:defRPr/>
+                      </a:pPr>
+                      <a:r>
+                        <a:rPr kumimoji="0" lang="en-GB" sz="1400" u="none" strike="noStrike" cap="none" normalizeH="0" baseline="0" dirty="0">
+                          <a:ln>
+                            <a:noFill/>
+                          </a:ln>
+                          <a:effectLst/>
+                        </a:rPr>
+                        <a:t>Sample text Column 1</a:t>
+                      </a:r>
+                      <a:endParaRPr kumimoji="0" lang="en-GB" sz="1400" b="1" i="0" u="none" strike="noStrike" cap="none" normalizeH="0" baseline="0" dirty="0">
+                        <a:ln>
+                          <a:noFill/>
+                        </a:ln>
+                        <a:solidFill>
+                          <a:srgbClr val="000066"/>
+                        </a:solidFill>
+                        <a:effectLst/>
+                        <a:latin typeface="Verdana" pitchFamily="34" charset="0"/>
+                      </a:endParaRPr>
+                    </a:p>
+                  </a:txBody>
+                  <a:tcPr marT="38100" marB="38100"/>
+                </a:tc>
+                <a:tc>
+                  <a:txBody>
+                    <a:bodyPr/>
+                    <a:lstStyle/>
+                    <a:p>
+                      <a:pPr marL="0" marR="0" lvl="0" indent="0" algn="l" defTabSz="914400" rtl="0" eaLnBrk="1" fontAlgn="base" latinLnBrk="0" hangingPunct="1">
+                        <a:lnSpc>
+                          <a:spcPct val="100000"/>
+                        </a:lnSpc>
+                        <a:spcBef>
+                          <a:spcPct val="0"/>
+                        </a:spcBef>
+                        <a:spcAft>
+                          <a:spcPct val="0"/>
+                        </a:spcAft>
+                        <a:buClr>
+                          <a:schemeClr val="bg2"/>
+                        </a:buClr>
+                        <a:buSzTx/>
+                        <a:buFontTx/>
+                        <a:buNone/>
+                        <a:tabLst/>
+                        <a:defRPr/>
+                      </a:pPr>
+                      <a:r>
+                        <a:rPr kumimoji="0" lang="en-GB" sz="1400" u="none" strike="noStrike" cap="none" normalizeH="0" baseline="0" dirty="0">
+                          <a:ln>
+                            <a:noFill/>
+                          </a:ln>
+                          <a:effectLst/>
+                        </a:rPr>
+                        <a:t>Sample text Column 2</a:t>
+                      </a:r>
+                      <a:endParaRPr kumimoji="0" lang="en-GB" sz="1400" b="1" i="0" u="none" strike="noStrike" cap="none" normalizeH="0" baseline="0" dirty="0">
+                        <a:ln>
+                          <a:noFill/>
+                        </a:ln>
+                        <a:solidFill>
+                          <a:srgbClr val="000066"/>
+                        </a:solidFill>
+                        <a:effectLst/>
+                        <a:latin typeface="Verdana" pitchFamily="34" charset="0"/>
+                      </a:endParaRPr>
+                    </a:p>
+                  </a:txBody>
+                  <a:tcPr marT="38100" marB="38100"/>
+                </a:tc>
+                <a:tc>
+                  <a:txBody>
+                    <a:bodyPr/>
+                    <a:lstStyle/>
+                    <a:p>
+                      <a:pPr marL="0" marR="0" lvl="0" indent="0" algn="l" defTabSz="914400" rtl="0" eaLnBrk="1" fontAlgn="base" latinLnBrk="0" hangingPunct="1">
+                        <a:lnSpc>
+                          <a:spcPct val="100000"/>
+                        </a:lnSpc>
+                        <a:spcBef>
+                          <a:spcPct val="0"/>
+                        </a:spcBef>
+                        <a:spcAft>
+                          <a:spcPct val="0"/>
+                        </a:spcAft>
+                        <a:buClr>
+                          <a:schemeClr val="bg2"/>
+                        </a:buClr>
+                        <a:buSzTx/>
+                        <a:buFontTx/>
+                        <a:buNone/>
+                        <a:tabLst/>
+                      </a:pPr>
+                      <a:r>
+                        <a:rPr kumimoji="0" lang="en-GB" sz="1400" u="none" strike="noStrike" cap="none" normalizeH="0" baseline="0" dirty="0">
+                          <a:ln>
+                            <a:noFill/>
+                          </a:ln>
+                          <a:effectLst/>
+                        </a:rPr>
+                        <a:t>Sample text Column 3</a:t>
+                      </a:r>
+                      <a:endParaRPr kumimoji="0" lang="en-GB" sz="1400" b="1" i="0" u="none" strike="noStrike" cap="none" normalizeH="0" baseline="0" dirty="0">
+                        <a:ln>
+                          <a:noFill/>
+                        </a:ln>
+                        <a:solidFill>
+                          <a:srgbClr val="000066"/>
+                        </a:solidFill>
+                        <a:effectLst/>
+                        <a:latin typeface="Verdana" pitchFamily="34" charset="0"/>
+                      </a:endParaRPr>
+                    </a:p>
+                  </a:txBody>
+                  <a:tcPr marT="38100" marB="38100"/>
+                </a:tc>
+                <a:extLst>
+                  <a:ext uri="{0D108BD9-81ED-4DB2-BD59-A6C34878D82A}">
+                    <a16:rowId xmlns:a16="http://schemas.microsoft.com/office/drawing/2014/main" val="10006"/>
+                  </a:ext>
+                </a:extLst>
+              </a:tr>
+            </a:tbl>
+          </a:graphicData>
+        </a:graphic>
+      </p:graphicFrame>
+    </p:spTree>
+    <p:extLst>
+      <p:ext uri="{BB962C8B-B14F-4D97-AF65-F5344CB8AC3E}">
+        <p14:creationId xmlns:p14="http://schemas.microsoft.com/office/powerpoint/2010/main" val="3543249116"/>
       </p:ext>
     </p:extLst>
   </p:cSld>

</xml_diff>

<commit_message>
Template: contact details on Titelfolie Kontakt and new Abschlussfolie Kontakt business card; skill lists presenter details
Co-Authored-By: Claude Sonnet 5.5 <noreply@anthropic.com>
Claude-Session: https://claude.ai/code/session_01RkWScMhuRmEB4zppSmB7Ri
</commit_message>
<xml_diff>
--- a/WT26-27/template.pptx
+++ b/WT26-27/template.pptx
@@ -19018,24 +19018,28 @@
       </p:sp>
       <p:sp>
         <p:nvSpPr>
-          <p:cNvPr id="10" name="Textplatzhalter 9"/>
+          <p:cNvPr id="10" name="Kontaktdaten"/>
           <p:cNvSpPr>
             <a:spLocks noGrp="1"/>
           </p:cNvSpPr>
-          <p:nvPr>
-            <p:ph type="body" sz="quarter" idx="11" hasCustomPrompt="1"/>
-          </p:nvPr>
+          <p:nvPr userDrawn="1"/>
         </p:nvSpPr>
         <p:spPr bwMode="white">
           <a:xfrm>
             <a:off x="287338" y="2941638"/>
             <a:ext cx="4284662" cy="1400000"/>
           </a:xfrm>
+          <a:prstGeom prst="rect">
+            <a:avLst/>
+          </a:prstGeom>
           <a:solidFill>
-            <a:schemeClr val="bg1">
+            <a:srgbClr val="FFFFFF">
               <a:alpha val="90000"/>
-            </a:schemeClr>
+            </a:srgbClr>
           </a:solidFill>
+          <a:ln>
+            <a:noFill/>
+          </a:ln>
         </p:spPr>
         <p:txBody>
           <a:bodyPr wrap="square" lIns="324000" tIns="216000" rIns="324000" bIns="216000" rtlCol="0" anchor="t" anchorCtr="0">
@@ -19048,27 +19052,61 @@
             </a:lvl1pPr>
           </a:lstStyle>
           <a:p>
-            <a:r>
-              <a:rPr lang="en-GB" dirty="0"/>
-              <a:t>Name and position</a:t>
-            </a:r>
-          </a:p>
-          <a:p>
-            <a:r>
-              <a:rPr lang="en-GB" dirty="0"/>
-              <a:t>Institute</a:t>
-            </a:r>
-          </a:p>
-          <a:p>
-            <a:r>
-              <a:rPr lang="en-GB" dirty="0"/>
-              <a:t>E-mail address</a:t>
-            </a:r>
-          </a:p>
-          <a:p>
-            <a:r>
-              <a:rPr lang="en-GB" dirty="0"/>
-              <a:t>Link, e.g. to office hours</a:t>
+            <a:pPr marL="0" indent="0">
+              <a:buNone/>
+            </a:pPr>
+            <a:r>
+              <a:rPr lang="en-GB" sz="1100" dirty="0">
+                <a:solidFill>
+                  <a:srgbClr val="000000"/>
+                </a:solidFill>
+                <a:latin typeface="+mn-lt"/>
+              </a:rPr>
+              <a:t>Dr Arne Floh, Senior Lecturer in Marketing</a:t>
+            </a:r>
+          </a:p>
+          <a:p>
+            <a:pPr marL="0" indent="0">
+              <a:buNone/>
+            </a:pPr>
+            <a:r>
+              <a:rPr lang="en-GB" sz="1100" dirty="0">
+                <a:solidFill>
+                  <a:srgbClr val="000000"/>
+                </a:solidFill>
+                <a:latin typeface="+mn-lt"/>
+              </a:rPr>
+              <a:t>WU Vienna, Institute for International Business</a:t>
+            </a:r>
+          </a:p>
+          <a:p>
+            <a:pPr marL="0" indent="0">
+              <a:buNone/>
+            </a:pPr>
+            <a:r>
+              <a:rPr lang="en-GB" sz="1100" dirty="0">
+                <a:solidFill>
+                  <a:srgbClr val="000000"/>
+                </a:solidFill>
+                <a:latin typeface="+mn-lt"/>
+                <a:hlinkClick r:id="rId20"/>
+              </a:rPr>
+              <a:t>arne.floh@wu.ac.at</a:t>
+            </a:r>
+          </a:p>
+          <a:p>
+            <a:pPr marL="0" indent="0">
+              <a:buNone/>
+            </a:pPr>
+            <a:r>
+              <a:rPr lang="en-GB" sz="1100" dirty="0">
+                <a:solidFill>
+                  <a:srgbClr val="000000"/>
+                </a:solidFill>
+                <a:latin typeface="+mn-lt"/>
+                <a:hlinkClick r:id="rId21"/>
+              </a:rPr>
+              <a:t>Office hours: book online (Google Calendar)</a:t>
             </a:r>
           </a:p>
         </p:txBody>
@@ -19670,6 +19708,363 @@
               <a:rPr lang="de-DE"/>
               <a:t>Mastertitelformat bearbeiten</a:t>
             </a:r>
+            <a:endParaRPr lang="en-GB" dirty="0"/>
+          </a:p>
+        </p:txBody>
+      </p:sp>
+    </p:spTree>
+  </p:cSld>
+  <p:clrMapOvr>
+    <a:masterClrMapping/>
+  </p:clrMapOvr>
+  <p:transition>
+    <p:fade/>
+  </p:transition>
+</p:sldLayout>
+</file>
+
+<file path=ppt/slideLayouts/slideLayout19.xml><?xml version="1.0" encoding="utf-8"?>
+<p:sldLayout xmlns:a="http://schemas.openxmlformats.org/drawingml/2006/main" xmlns:r="http://schemas.openxmlformats.org/officeDocument/2006/relationships" xmlns:p="http://schemas.openxmlformats.org/presentationml/2006/main" preserve="1" userDrawn="1">
+  <p:cSld name="Abschlussfolie Kontakt">
+    <p:spTree>
+      <p:nvGrpSpPr>
+        <p:cNvPr id="1" name=""/>
+        <p:cNvGrpSpPr/>
+        <p:nvPr/>
+      </p:nvGrpSpPr>
+      <p:grpSpPr>
+        <a:xfrm>
+          <a:off x="0" y="0"/>
+          <a:ext cx="0" cy="0"/>
+          <a:chOff x="0" y="0"/>
+          <a:chExt cx="0" cy="0"/>
+        </a:xfrm>
+      </p:grpSpPr>
+      <p:sp>
+        <p:nvSpPr>
+          <p:cNvPr id="5" name="Rechteck 4"/>
+          <p:cNvSpPr/>
+          <p:nvPr/>
+        </p:nvSpPr>
+        <p:spPr>
+          <a:xfrm>
+            <a:off x="467544" y="1964530"/>
+            <a:ext cx="4319712" cy="2716954"/>
+          </a:xfrm>
+          <a:prstGeom prst="rect">
+            <a:avLst/>
+          </a:prstGeom>
+          <a:ln w="12700">
+            <a:solidFill>
+              <a:schemeClr val="bg1">
+                <a:lumMod val="50000"/>
+              </a:schemeClr>
+            </a:solidFill>
+          </a:ln>
+          <a:effectLst/>
+        </p:spPr>
+        <p:style>
+          <a:lnRef idx="2">
+            <a:schemeClr val="dk1"/>
+          </a:lnRef>
+          <a:fillRef idx="1">
+            <a:schemeClr val="lt1"/>
+          </a:fillRef>
+          <a:effectRef idx="0">
+            <a:schemeClr val="dk1"/>
+          </a:effectRef>
+          <a:fontRef idx="minor">
+            <a:schemeClr val="dk1"/>
+          </a:fontRef>
+        </p:style>
+        <p:txBody>
+          <a:bodyPr lIns="91431" tIns="45715" rIns="91431" bIns="45715" rtlCol="0" anchor="ctr"/>
+          <a:lstStyle/>
+          <a:p>
+            <a:pPr algn="ctr"/>
+            <a:endParaRPr lang="en-GB" dirty="0"/>
+          </a:p>
+        </p:txBody>
+      </p:sp>
+      <p:pic>
+        <p:nvPicPr>
+          <p:cNvPr id="7" name="Grafik 6" descr="Logo-für-VK.png"/>
+          <p:cNvPicPr>
+            <a:picLocks noChangeAspect="1"/>
+          </p:cNvPicPr>
+          <p:nvPr/>
+        </p:nvPicPr>
+        <p:blipFill>
+          <a:blip r:embed="rId2" cstate="print"/>
+          <a:stretch>
+            <a:fillRect/>
+          </a:stretch>
+        </p:blipFill>
+        <p:spPr>
+          <a:xfrm>
+            <a:off x="611560" y="2127250"/>
+            <a:ext cx="492443" cy="2252663"/>
+          </a:xfrm>
+          <a:prstGeom prst="rect">
+            <a:avLst/>
+          </a:prstGeom>
+        </p:spPr>
+      </p:pic>
+      <p:sp>
+        <p:nvSpPr>
+          <p:cNvPr id="11" name="Kontaktdaten"/>
+          <p:cNvSpPr>
+            <a:spLocks noGrp="1"/>
+          </p:cNvSpPr>
+          <p:nvPr userDrawn="1"/>
+        </p:nvSpPr>
+        <p:spPr>
+          <a:xfrm>
+            <a:off x="1684020" y="2559843"/>
+            <a:ext cx="2763926" cy="1811291"/>
+          </a:xfrm>
+          <a:prstGeom prst="rect">
+            <a:avLst/>
+          </a:prstGeom>
+        </p:spPr>
+        <p:txBody>
+          <a:bodyPr>
+            <a:normAutofit/>
+          </a:bodyPr>
+          <a:lstStyle>
+            <a:lvl1pPr marL="0" marR="0" indent="0" algn="l" defTabSz="914306" rtl="0" eaLnBrk="1" fontAlgn="auto" latinLnBrk="0" hangingPunct="1">
+              <a:lnSpc>
+                <a:spcPct val="100000"/>
+              </a:lnSpc>
+              <a:spcBef>
+                <a:spcPts val="0"/>
+              </a:spcBef>
+              <a:spcAft>
+                <a:spcPts val="0"/>
+              </a:spcAft>
+              <a:buClr>
+                <a:srgbClr val="4B2582"/>
+              </a:buClr>
+              <a:buSzTx/>
+              <a:buFont typeface="Wingdings" pitchFamily="2" charset="2"/>
+              <a:buNone/>
+              <a:tabLst/>
+              <a:defRPr sz="1100" baseline="0"/>
+            </a:lvl1pPr>
+            <a:lvl2pPr marL="0" indent="0">
+              <a:buNone/>
+              <a:defRPr/>
+            </a:lvl2pPr>
+            <a:lvl3pPr marL="0" indent="0">
+              <a:buNone/>
+              <a:defRPr/>
+            </a:lvl3pPr>
+            <a:lvl4pPr marL="0" indent="0">
+              <a:buNone/>
+              <a:defRPr/>
+            </a:lvl4pPr>
+            <a:lvl5pPr marL="0" indent="0">
+              <a:buNone/>
+              <a:defRPr/>
+            </a:lvl5pPr>
+          </a:lstStyle>
+          <a:p>
+            <a:pPr marL="0" indent="0">
+              <a:buNone/>
+            </a:pPr>
+            <a:r>
+              <a:rPr lang="en-GB" sz="1000" b="1" dirty="0">
+                <a:solidFill>
+                  <a:srgbClr val="000000"/>
+                </a:solidFill>
+                <a:latin typeface="+mn-lt"/>
+              </a:rPr>
+              <a:t>INSTITUTE FOR INTERNATIONAL BUSINESS</a:t>
+            </a:r>
+          </a:p>
+          <a:p>
+            <a:pPr marL="0" indent="0">
+              <a:buNone/>
+            </a:pPr>
+            <a:r>
+              <a:rPr lang="en-GB" sz="1000" dirty="0">
+                <a:solidFill>
+                  <a:srgbClr val="000000"/>
+                </a:solidFill>
+                <a:latin typeface="+mn-lt"/>
+              </a:rPr>
+              <a:t>Welthandelsplatz 1, 1020 Vienna, Austria</a:t>
+            </a:r>
+          </a:p>
+          <a:p>
+            <a:pPr marL="0" indent="0">
+              <a:buNone/>
+            </a:pPr>
+            <a:endParaRPr lang="en-GB" sz="1000" dirty="0"/>
+          </a:p>
+          <a:p>
+            <a:pPr marL="0" indent="0">
+              <a:buNone/>
+            </a:pPr>
+            <a:r>
+              <a:rPr lang="en-GB" sz="1000" b="1" dirty="0">
+                <a:solidFill>
+                  <a:srgbClr val="000000"/>
+                </a:solidFill>
+                <a:latin typeface="+mn-lt"/>
+              </a:rPr>
+              <a:t>DR ARNE FLOH</a:t>
+            </a:r>
+          </a:p>
+          <a:p>
+            <a:pPr marL="0" indent="0">
+              <a:buNone/>
+            </a:pPr>
+            <a:r>
+              <a:rPr lang="en-GB" sz="1000" dirty="0">
+                <a:solidFill>
+                  <a:srgbClr val="000000"/>
+                </a:solidFill>
+                <a:latin typeface="+mn-lt"/>
+              </a:rPr>
+              <a:t>Senior Lecturer in Marketing</a:t>
+            </a:r>
+          </a:p>
+          <a:p>
+            <a:pPr marL="0" indent="0">
+              <a:buNone/>
+            </a:pPr>
+            <a:endParaRPr lang="en-GB" sz="1000" dirty="0"/>
+          </a:p>
+          <a:p>
+            <a:pPr marL="0" indent="0">
+              <a:buNone/>
+            </a:pPr>
+            <a:r>
+              <a:rPr lang="en-GB" sz="1000" dirty="0">
+                <a:solidFill>
+                  <a:srgbClr val="000000"/>
+                </a:solidFill>
+                <a:latin typeface="+mn-lt"/>
+              </a:rPr>
+              <a:t>F +43-31336-6367</a:t>
+            </a:r>
+          </a:p>
+          <a:p>
+            <a:pPr marL="0" indent="0">
+              <a:buNone/>
+            </a:pPr>
+            <a:r>
+              <a:rPr lang="en-GB" sz="1000" dirty="0">
+                <a:solidFill>
+                  <a:srgbClr val="000000"/>
+                </a:solidFill>
+                <a:latin typeface="+mn-lt"/>
+                <a:hlinkClick r:id="rId20"/>
+              </a:rPr>
+              <a:t>arne.floh@wu.ac.at</a:t>
+            </a:r>
+          </a:p>
+          <a:p>
+            <a:pPr marL="0" indent="0">
+              <a:buNone/>
+            </a:pPr>
+            <a:r>
+              <a:rPr lang="en-GB" sz="900" dirty="0">
+                <a:solidFill>
+                  <a:srgbClr val="000000"/>
+                </a:solidFill>
+                <a:latin typeface="+mn-lt"/>
+                <a:hlinkClick r:id="rId22"/>
+              </a:rPr>
+              <a:t>www.wu.ac.at/en/welthandel/arne-floh</a:t>
+            </a:r>
+          </a:p>
+          <a:p>
+            <a:pPr marL="0" indent="0">
+              <a:buNone/>
+            </a:pPr>
+            <a:r>
+              <a:rPr lang="en-GB" sz="1000" dirty="0">
+                <a:solidFill>
+                  <a:srgbClr val="000000"/>
+                </a:solidFill>
+                <a:latin typeface="+mn-lt"/>
+                <a:hlinkClick r:id="rId21"/>
+              </a:rPr>
+              <a:t>Office hours: book online</a:t>
+            </a:r>
+          </a:p>
+        </p:txBody>
+      </p:sp>
+      <p:sp>
+        <p:nvSpPr>
+          <p:cNvPr id="8" name="Datumsplatzhalter 7"/>
+          <p:cNvSpPr>
+            <a:spLocks noGrp="1"/>
+          </p:cNvSpPr>
+          <p:nvPr>
+            <p:ph type="dt" sz="half" idx="11"/>
+          </p:nvPr>
+        </p:nvSpPr>
+        <p:spPr/>
+        <p:txBody>
+          <a:bodyPr/>
+          <a:lstStyle/>
+          <a:p>
+            <a:fld id="{D1DA7DE9-F6B6-4FDA-A00F-1221D494593B}" type="datetime1">
+              <a:rPr lang="en-GB" smtClean="0"/>
+              <a:t>25/08/2023</a:t>
+            </a:fld>
+            <a:endParaRPr lang="en-GB" dirty="0"/>
+          </a:p>
+        </p:txBody>
+      </p:sp>
+      <p:sp>
+        <p:nvSpPr>
+          <p:cNvPr id="9" name="Fußzeilenplatzhalter 8"/>
+          <p:cNvSpPr>
+            <a:spLocks noGrp="1"/>
+          </p:cNvSpPr>
+          <p:nvPr>
+            <p:ph type="ftr" sz="quarter" idx="12"/>
+          </p:nvPr>
+        </p:nvSpPr>
+        <p:spPr/>
+        <p:txBody>
+          <a:bodyPr/>
+          <a:lstStyle/>
+          <a:p>
+            <a:r>
+              <a:rPr lang="en-GB" dirty="0"/>
+              <a:t>Sample Footer</a:t>
+            </a:r>
+          </a:p>
+        </p:txBody>
+      </p:sp>
+      <p:sp>
+        <p:nvSpPr>
+          <p:cNvPr id="10" name="Foliennummernplatzhalter 9"/>
+          <p:cNvSpPr>
+            <a:spLocks noGrp="1"/>
+          </p:cNvSpPr>
+          <p:nvPr>
+            <p:ph type="sldNum" sz="quarter" idx="13"/>
+          </p:nvPr>
+        </p:nvSpPr>
+        <p:spPr/>
+        <p:txBody>
+          <a:bodyPr/>
+          <a:lstStyle/>
+          <a:p>
+            <a:r>
+              <a:rPr lang="en-GB" dirty="0"/>
+              <a:t>Page </a:t>
+            </a:r>
+            <a:fld id="{BE3DC40E-DBBE-4E2D-9EEC-FBF0DA0E9179}" type="slidenum">
+              <a:rPr lang="en-GB" smtClean="0"/>
+              <a:t>‹Nr.›</a:t>
+            </a:fld>
             <a:endParaRPr lang="en-GB" dirty="0"/>
           </a:p>
         </p:txBody>
@@ -23799,6 +24194,7 @@
     <p:sldLayoutId id="2147483692" r:id="rId19"/>
     <p:sldLayoutId id="2147483693" r:id="rId20"/>
     <p:sldLayoutId id="2147483694" r:id="rId21"/>
+    <p:sldLayoutId id="2147483695" r:id="rId22"/>
   </p:sldLayoutIdLst>
   <p:transition>
     <p:fade/>
@@ -29347,114 +29743,6 @@
       </p:grpSpPr>
       <p:sp>
         <p:nvSpPr>
-          <p:cNvPr id="8" name="Textplatzhalter 3"/>
-          <p:cNvSpPr txBox="1">
-            <a:spLocks noGrp="1"/>
-          </p:cNvSpPr>
-          <p:nvPr>
-            <p:ph type="body" sz="quarter" idx="10"/>
-          </p:nvPr>
-        </p:nvSpPr>
-        <p:spPr>
-          <a:xfrm>
-            <a:off x="1691680" y="2559843"/>
-            <a:ext cx="2756266" cy="1811291"/>
-          </a:xfrm>
-        </p:spPr>
-        <p:txBody>
-          <a:bodyPr>
-            <a:normAutofit fontScale="92500" lnSpcReduction="10000"/>
-          </a:bodyPr>
-          <a:lstStyle/>
-          <a:p>
-            <a:pPr lvl="0"/>
-            <a:r>
-              <a:rPr lang="en-GB" b="1" noProof="0" dirty="0"/>
-              <a:t>DEPARTMENT MUSTERTEXT DEUTSCH</a:t>
-            </a:r>
-          </a:p>
-          <a:p>
-            <a:pPr lvl="0"/>
-            <a:r>
-              <a:rPr lang="en-GB" noProof="0" dirty="0"/>
-              <a:t>DEPARTMENT MUSTERTEXT ENGLISH</a:t>
-            </a:r>
-          </a:p>
-          <a:p>
-            <a:pPr lvl="0">
-              <a:buClr>
-                <a:schemeClr val="accent3"/>
-              </a:buClr>
-              <a:defRPr/>
-            </a:pPr>
-            <a:r>
-              <a:rPr lang="en-GB" dirty="0" err="1"/>
-              <a:t>Welthandelsplatz</a:t>
-            </a:r>
-            <a:r>
-              <a:rPr lang="en-GB" dirty="0"/>
-              <a:t> 1, 1020 Vienna, Austria</a:t>
-            </a:r>
-          </a:p>
-          <a:p>
-            <a:pPr lvl="0"/>
-            <a:endParaRPr lang="en-GB" noProof="0" dirty="0"/>
-          </a:p>
-          <a:p>
-            <a:pPr lvl="0"/>
-            <a:endParaRPr lang="en-GB" noProof="0" dirty="0"/>
-          </a:p>
-          <a:p>
-            <a:pPr lvl="0"/>
-            <a:endParaRPr lang="en-GB" noProof="0" dirty="0"/>
-          </a:p>
-          <a:p>
-            <a:pPr lvl="0"/>
-            <a:r>
-              <a:rPr lang="en-GB" b="1" noProof="0" dirty="0"/>
-              <a:t>UNIV.PROF.  DR. MAX MUSTER</a:t>
-            </a:r>
-          </a:p>
-          <a:p>
-            <a:pPr lvl="0"/>
-            <a:endParaRPr lang="en-GB" noProof="0" dirty="0"/>
-          </a:p>
-          <a:p>
-            <a:pPr lvl="0"/>
-            <a:r>
-              <a:rPr lang="en-GB" noProof="0" dirty="0"/>
-              <a:t>T +43-1-313 36-DW</a:t>
-            </a:r>
-          </a:p>
-          <a:p>
-            <a:pPr lvl="0"/>
-            <a:r>
-              <a:rPr lang="en-GB" noProof="0" dirty="0"/>
-              <a:t>F +43-1-313 36-DW</a:t>
-            </a:r>
-          </a:p>
-          <a:p>
-            <a:pPr lvl="0"/>
-            <a:r>
-              <a:rPr lang="en-GB" noProof="0" dirty="0"/>
-              <a:t>max.muster@wu.ac.at</a:t>
-            </a:r>
-          </a:p>
-          <a:p>
-            <a:pPr lvl="0"/>
-            <a:r>
-              <a:rPr lang="en-GB" noProof="0" dirty="0"/>
-              <a:t>www.wu.ac.at</a:t>
-            </a:r>
-          </a:p>
-          <a:p>
-            <a:pPr lvl="0"/>
-            <a:endParaRPr lang="en-GB" noProof="0" dirty="0"/>
-          </a:p>
-        </p:txBody>
-      </p:sp>
-      <p:sp>
-        <p:nvSpPr>
           <p:cNvPr id="7" name="Titel 6"/>
           <p:cNvSpPr>
             <a:spLocks noGrp="1"/>
@@ -29605,50 +29893,6 @@
             <a:r>
               <a:rPr lang="en-GB" dirty="0"/>
               <a:t>Subtitle of presentation</a:t>
-            </a:r>
-          </a:p>
-        </p:txBody>
-      </p:sp>
-      <p:sp>
-        <p:nvSpPr>
-          <p:cNvPr id="4" name="Textplatzhalter 3"/>
-          <p:cNvSpPr>
-            <a:spLocks noGrp="1"/>
-          </p:cNvSpPr>
-          <p:nvPr>
-            <p:ph type="body" sz="quarter" idx="11"/>
-          </p:nvPr>
-        </p:nvSpPr>
-        <p:spPr/>
-        <p:txBody>
-          <a:bodyPr/>
-          <a:lstStyle/>
-          <a:p>
-            <a:pPr lvl="0"/>
-            <a:r>
-              <a:rPr lang="en-GB" dirty="0"/>
-              <a:t>Name and position</a:t>
-            </a:r>
-          </a:p>
-          <a:p>
-            <a:pPr lvl="0"/>
-            <a:r>
-              <a:rPr lang="en-GB" dirty="0"/>
-              <a:t>Institute</a:t>
-            </a:r>
-          </a:p>
-          <a:p>
-            <a:pPr lvl="0"/>
-            <a:r>
-              <a:rPr lang="en-GB" dirty="0"/>
-              <a:t>name@wu.ac.at</a:t>
-            </a:r>
-          </a:p>
-          <a:p>
-            <a:pPr lvl="0"/>
-            <a:r>
-              <a:rPr lang="en-GB" dirty="0"/>
-              <a:t>Link, e.g. to office hours</a:t>
             </a:r>
           </a:p>
         </p:txBody>

</xml_diff>